<commit_message>
Form 3 L14-L22 and FS2: revise to the validated model
Co-Authored-By: Claude Opus 5.5 <noreply@anthropic.com>
Claude-Session: https://claude.ai/code/session_0115LFSb2ktGLWPeVksFkSer
</commit_message>
<xml_diff>
--- a/lecons/F3/17_FORM4_LESSON14_Denudation.pptx
+++ b/lecons/F3/17_FORM4_LESSON14_Denudation.pptx
@@ -50,9 +50,12 @@
     <p:sldId id="298" r:id="rId44"/>
     <p:sldId id="299" r:id="rId45"/>
     <p:sldId id="300" r:id="rId46"/>
+    <p:sldId id="301" r:id="rId47"/>
+    <p:sldId id="302" r:id="rId48"/>
+    <p:sldId id="303" r:id="rId49"/>
   </p:sldIdLst>
   <p:notesMasterIdLst>
-    <p:notesMasterId r:id="rId47"/>
+    <p:notesMasterId r:id="rId50"/>
   </p:notesMasterIdLst>
   <p:sldSz cx="12192000" cy="6858000"/>
   <p:notesSz cx="6858000" cy="12192000"/>
@@ -722,7 +725,7 @@
           <a:p>
             <a:r>
               <a:rPr lang="en-US" dirty="0"/>
-              <a:t>Good. Halima does not know how water changes the land.</a:t>
+              <a:t>Good. Halima does not know how the land is worn down and by which forces.</a:t>
             </a:r>
             <a:endParaRPr lang="en-US" dirty="0"/>
           </a:p>
@@ -810,7 +813,7 @@
           <a:p>
             <a:r>
               <a:rPr lang="en-US" dirty="0"/>
-              <a:t>Question 2: What did the water do? Think for a moment, then raise your hand to answer.</a:t>
+              <a:t>Question 2: What did the water carry? Think for a moment, then raise your hand to answer.</a:t>
             </a:r>
             <a:endParaRPr lang="en-US" dirty="0"/>
           </a:p>
@@ -898,7 +901,7 @@
           <a:p>
             <a:r>
               <a:rPr lang="en-US" dirty="0"/>
-              <a:t>Good. It cut a channel, carried sand and stones, and dropped them.</a:t>
+              <a:t>Good. Sand and stones.</a:t>
             </a:r>
             <a:endParaRPr lang="en-US" dirty="0"/>
           </a:p>
@@ -986,7 +989,7 @@
           <a:p>
             <a:r>
               <a:rPr lang="en-US" dirty="0"/>
-              <a:t>Question 3: What do we call this wearing down of the land? Think for a moment, then raise your hand to answer.</a:t>
+              <a:t>Question 3: Which force wore away the soil here? Think for a moment, then raise your hand to answer.</a:t>
             </a:r>
             <a:endParaRPr lang="en-US" dirty="0"/>
           </a:p>
@@ -1074,7 +1077,7 @@
           <a:p>
             <a:r>
               <a:rPr lang="en-US" dirty="0"/>
-              <a:t>Good. Denudation.</a:t>
+              <a:t>Good. Running water (rain water).</a:t>
             </a:r>
             <a:endParaRPr lang="en-US" dirty="0"/>
           </a:p>
@@ -1338,7 +1341,7 @@
           <a:p>
             <a:r>
               <a:rPr lang="en-US" dirty="0"/>
-              <a:t>Activity 1. Look carefully at this picture: a channel cut by rain water in red soil. Observe every detail before I ask the question.</a:t>
+              <a:t>Activity 1. Look carefully at this picture: a channel cut by rain water. Observe every detail before I ask the question.</a:t>
             </a:r>
             <a:endParaRPr lang="en-US" dirty="0"/>
           </a:p>
@@ -1690,7 +1693,7 @@
           <a:p>
             <a:r>
               <a:rPr lang="en-US" dirty="0"/>
-              <a:t>Activity 2. Look carefully at this animation: animation: the four processes of denudation. Watch the animation to the end; it will play again.</a:t>
+              <a:t>Activity 2. Look carefully at this animation: animation: the processes of denudation. Watch the animation to the end; it will play again.</a:t>
             </a:r>
             <a:endParaRPr lang="en-US" dirty="0"/>
           </a:p>
@@ -1778,7 +1781,7 @@
           <a:p>
             <a:r>
               <a:rPr lang="en-US" dirty="0"/>
-              <a:t>Here is the question for Activity 2: Name the four processes in the right order. Take one minute to think and write your answer in your rough notebook.</a:t>
+              <a:t>Here is the question for Activity 2: What happens to the rock before it can be carried away? Take one minute to think and write your answer in your rough notebook.</a:t>
             </a:r>
             <a:endParaRPr lang="en-US" dirty="0"/>
           </a:p>
@@ -1866,7 +1869,7 @@
           <a:p>
             <a:r>
               <a:rPr lang="en-US" dirty="0"/>
-              <a:t>Let us check the answer together. Weathering, erosion, transport, deposition.</a:t>
+              <a:t>Let us check the answer together. It is broken down in its place: this is weathering.</a:t>
             </a:r>
             <a:endParaRPr lang="en-US" dirty="0"/>
           </a:p>
@@ -1954,7 +1957,7 @@
           <a:p>
             <a:r>
               <a:rPr lang="en-US" dirty="0"/>
-              <a:t>Activity 3. Look carefully at this picture: a muddy river seen from space. Observe every detail before I ask the question.</a:t>
+              <a:t>Activity 3. Look carefully at this picture: a muddy river. Observe every detail before I ask the question.</a:t>
             </a:r>
             <a:endParaRPr lang="en-US" dirty="0"/>
           </a:p>
@@ -2042,7 +2045,7 @@
           <a:p>
             <a:r>
               <a:rPr lang="en-US" dirty="0"/>
-              <a:t>Here is the question for Activity 3: Which agent carries the mud? Name two other agents. Take one minute to think and write your answer in your rough notebook.</a:t>
+              <a:t>Here is the question for Activity 3: Which agent carries this mud? Take one minute to think and write your answer in your rough notebook.</a:t>
             </a:r>
             <a:endParaRPr lang="en-US" dirty="0"/>
           </a:p>
@@ -2130,7 +2133,7 @@
           <a:p>
             <a:r>
               <a:rPr lang="en-US" dirty="0"/>
-              <a:t>Let us check the answer together. Running water. Others: wind, waves, ice.</a:t>
+              <a:t>Let us check the answer together. Running water.</a:t>
             </a:r>
             <a:endParaRPr lang="en-US" dirty="0"/>
           </a:p>
@@ -2218,7 +2221,7 @@
           <a:p>
             <a:r>
               <a:rPr lang="en-US" dirty="0"/>
-              <a:t>Now we are going to copy the board summary. Write the title and the headings neatly in your notebooks. I will give you enough time for each slide, so do not rush.</a:t>
+              <a:t>Here is the next question: Name another agent of denudation. Take one minute to think and write your answer in your rough notebook.</a:t>
             </a:r>
             <a:endParaRPr lang="en-US" dirty="0"/>
           </a:p>
@@ -2306,7 +2309,7 @@
           <a:p>
             <a:r>
               <a:rPr lang="en-US" dirty="0"/>
-              <a:t>Let us copy Meaning of Denudation. Denudation is defined as follows. On this slide we have Denudation. Write each point on a new line, with the key term first, and explain it in your own words when we revise.</a:t>
+              <a:t>Let us check the answer together. Wind (or waves).</a:t>
             </a:r>
             <a:endParaRPr lang="en-US" dirty="0"/>
           </a:p>
@@ -2394,7 +2397,7 @@
           <a:p>
             <a:r>
               <a:rPr lang="en-US" dirty="0"/>
-              <a:t>Let us copy Processes of Denudation. Denudation takes place through the following processes. On this slide we have Weathering and Erosion. Write each point on a new line, with the key term first, and explain it in your own words when we revise. When you finish, we go to the next slide.</a:t>
+              <a:t>Now we are going to copy the board summary. Write the title and the headings neatly in your notebooks. I will give you enough time for each slide, so do not rush.</a:t>
             </a:r>
             <a:endParaRPr lang="en-US" dirty="0"/>
           </a:p>
@@ -2570,7 +2573,7 @@
           <a:p>
             <a:r>
               <a:rPr lang="en-US" dirty="0"/>
-              <a:t>We continue with Processes of Denudation. On this slide we have Transportation and Deposition. Write each point on a new line, with the key term first, and explain it in your own words when we revise.</a:t>
+              <a:t>Let us copy the definitions. The key terms of this lesson are defined as follows. On this slide we have Denudation. Write each point on a new line, with the key term first, and explain it in your own words when we revise. When you finish, we go to the next slide.</a:t>
             </a:r>
             <a:endParaRPr lang="en-US" dirty="0"/>
           </a:p>
@@ -2658,7 +2661,7 @@
           <a:p>
             <a:r>
               <a:rPr lang="en-US" dirty="0"/>
-              <a:t>Now draw this illustration in your notebook: the processes of denudation. Give it a title and label it clearly.</a:t>
+              <a:t>We continue with the definitions. On this slide we have Agent of denudation. Write each point on a new line, with the key term first, and explain it in your own words when we revise.</a:t>
             </a:r>
             <a:endParaRPr lang="en-US" dirty="0"/>
           </a:p>
@@ -2746,7 +2749,7 @@
           <a:p>
             <a:r>
               <a:rPr lang="en-US" dirty="0"/>
-              <a:t>Let us copy Agents of Denudation. The main agents of denudation are the following. On this slide we have Running water and Wind. Write each point on a new line, with the key term first, and explain it in your own words when we revise. When you finish, we go to the next slide.</a:t>
+              <a:t>Let us copy Major Processes of Denudation. Denudation takes place through the following processes. Copy the point on Weathering on the left, then draw the diagram on the right: the processes of denudation. Give it a title and label it clearly.</a:t>
             </a:r>
             <a:endParaRPr lang="en-US" dirty="0"/>
           </a:p>
@@ -2834,7 +2837,7 @@
           <a:p>
             <a:r>
               <a:rPr lang="en-US" dirty="0"/>
-              <a:t>We continue with Agents of Denudation. On this slide we have Waves and Ice. Write each point on a new line, with the key term first, and explain it in your own words when we revise.</a:t>
+              <a:t>Copy the point on Erosion on the left, then draw the diagram on the right: erosion by rain water. Give it a title and label it clearly.</a:t>
             </a:r>
             <a:endParaRPr lang="en-US" dirty="0"/>
           </a:p>
@@ -2922,7 +2925,7 @@
           <a:p>
             <a:r>
               <a:rPr lang="en-US" dirty="0"/>
-              <a:t>Now let us check what you have understood. Question 1: What is denudation? Answer in your exercise book.</a:t>
+              <a:t>We continue with Major Processes of Denudation. On this slide we have Transportation. Write each point on a new line, with the key term first, and explain it in your own words when we revise.</a:t>
             </a:r>
             <a:endParaRPr lang="en-US" dirty="0"/>
           </a:p>
@@ -3010,7 +3013,7 @@
           <a:p>
             <a:r>
               <a:rPr lang="en-US" dirty="0"/>
-              <a:t>The expected answer is: the wearing down of the land. If you got it right, well done.</a:t>
+              <a:t>Let us copy Main Agents of Denudation. The main agents of denudation are the following. Copy the point on Running water on the left, then draw the diagram on the right: a muddy river. Give it a title and label it clearly.</a:t>
             </a:r>
             <a:endParaRPr lang="en-US" dirty="0"/>
           </a:p>
@@ -3098,7 +3101,7 @@
           <a:p>
             <a:r>
               <a:rPr lang="en-US" dirty="0"/>
-              <a:t>Now let us check what you have understood. Question 2: Name the four processes of denudation. Answer in your exercise book.</a:t>
+              <a:t>We continue with Main Agents of Denudation. On this slide we have Wind and Waves. Write each point on a new line, with the key term first, and explain it in your own words when we revise.</a:t>
             </a:r>
             <a:endParaRPr lang="en-US" dirty="0"/>
           </a:p>
@@ -3186,7 +3189,7 @@
           <a:p>
             <a:r>
               <a:rPr lang="en-US" dirty="0"/>
-              <a:t>The expected answer is: weathering, erosion, transport and deposition. If you got it right, well done.</a:t>
+              <a:t>Now let us check what you have understood. Question 1: What is denudation? Answer in your exercise book.</a:t>
             </a:r>
             <a:endParaRPr lang="en-US" dirty="0"/>
           </a:p>
@@ -3274,7 +3277,7 @@
           <a:p>
             <a:r>
               <a:rPr lang="en-US" dirty="0"/>
-              <a:t>For those who need more practice, fill in the blanks in your exercise book. The answers are: number 1, weathering; number 2, deposition; number 3, water.</a:t>
+              <a:t>The expected answer is: the wearing down of the land. If you got it right, well done.</a:t>
             </a:r>
             <a:endParaRPr lang="en-US" dirty="0"/>
           </a:p>
@@ -3362,7 +3365,7 @@
           <a:p>
             <a:r>
               <a:rPr lang="en-US" dirty="0"/>
-              <a:t>For your homework: Compare an old wall and a new wall in your area. Write three differences you see, and suggest what damaged the old wall. We shall correct it at the beginning of our next lesson.</a:t>
+              <a:t>Now let us check what you have understood. Question 2: Name the four processes of denudation. Answer in your exercise book.</a:t>
             </a:r>
             <a:endParaRPr lang="en-US" dirty="0"/>
           </a:p>
@@ -3538,7 +3541,7 @@
           <a:p>
             <a:r>
               <a:rPr lang="en-US" dirty="0"/>
-              <a:t>Our next lesson will be on Lesson 15: Weathering. Thank you for your attention, and see you next time.</a:t>
+              <a:t>The expected answer is: weathering, erosion, transport and deposition. If you got it right, well done.</a:t>
             </a:r>
             <a:endParaRPr lang="en-US" dirty="0"/>
           </a:p>
@@ -3626,7 +3629,7 @@
           <a:p>
             <a:r>
               <a:rPr lang="en-US" dirty="0"/>
-              <a:t>Let us play the bilingual game. I say a word in English, and you give me the French word. Then we do the reverse.</a:t>
+              <a:t>For those who need more practice, fill in the blanks in your exercise book. The answers are: number 1, weathering; number 2, deposition; number 3, water.</a:t>
             </a:r>
             <a:endParaRPr lang="en-US" dirty="0"/>
           </a:p>
@@ -3714,7 +3717,7 @@
           <a:p>
             <a:r>
               <a:rPr lang="en-US" dirty="0"/>
-              <a:t>I record this information in the official logbook of the class after the lesson.</a:t>
+              <a:t>For your homework: Compare an old wall and a new wall in your area. Write three differences you see, and suggest what damaged the old wall. We shall correct it at the beginning of our next lesson.</a:t>
             </a:r>
             <a:endParaRPr lang="en-US" dirty="0"/>
           </a:p>
@@ -3802,7 +3805,7 @@
           <a:p>
             <a:r>
               <a:rPr lang="en-US" dirty="0"/>
-              <a:t>I complete the second page of the logbook: the matter taught, the evaluation, the homework and the attendance.</a:t>
+              <a:t>Our next lesson will be on Lesson 15: Weathering. Thank you for your attention, and see you next time.</a:t>
             </a:r>
             <a:endParaRPr lang="en-US" dirty="0"/>
           </a:p>
@@ -3890,7 +3893,7 @@
           <a:p>
             <a:r>
               <a:rPr lang="en-US" dirty="0"/>
-              <a:t>This slide is for me, the teacher: it gives the timing of the lesson and what to do if the projector is not available.</a:t>
+              <a:t>Let us play the bilingual game. I say a word in English, and you give me the French word. Then we do the reverse.</a:t>
             </a:r>
             <a:endParaRPr lang="en-US" dirty="0"/>
           </a:p>
@@ -3978,7 +3981,7 @@
           <a:p>
             <a:r>
               <a:rPr lang="en-US" dirty="0"/>
-              <a:t>These are the references and picture credits used to prepare this lesson.</a:t>
+              <a:t>I record this information in the official logbook of the class after the lesson.</a:t>
             </a:r>
             <a:endParaRPr lang="en-US" dirty="0"/>
           </a:p>
@@ -4002,6 +4005,270 @@
             <a:fld id="{F7021451-1387-4CA6-816F-3879F97B5CBC}" type="slidenum">
               <a:rPr lang="en-US"/>
               <a:t>45</a:t>
+            </a:fld>
+            <a:endParaRPr lang="en-US"/>
+          </a:p>
+        </p:txBody>
+      </p:sp>
+    </p:spTree>
+    <p:extLst>
+      <p:ext uri="{BB962C8B-B14F-4D97-AF65-F5344CB8AC3E}">
+        <p14:creationId xmlns:p14="http://schemas.microsoft.com/office/powerpoint/2010/main" val="1024086991"/>
+      </p:ext>
+    </p:extLst>
+  </p:cSld>
+  <p:clrMapOvr>
+    <a:masterClrMapping/>
+  </p:clrMapOvr>
+</p:notes>
+</file>
+
+<file path=ppt/notesSlides/notesSlide46.xml><?xml version="1.0" encoding="utf-8"?>
+<p:notes xmlns:a="http://schemas.openxmlformats.org/drawingml/2006/main" xmlns:r="http://schemas.openxmlformats.org/officeDocument/2006/relationships" xmlns:p="http://schemas.openxmlformats.org/presentationml/2006/main">
+  <p:cSld>
+    <p:spTree>
+      <p:nvGrpSpPr>
+        <p:cNvPr id="1" name=""/>
+        <p:cNvGrpSpPr/>
+        <p:nvPr/>
+      </p:nvGrpSpPr>
+      <p:grpSpPr>
+        <a:xfrm>
+          <a:off x="0" y="0"/>
+          <a:ext cx="0" cy="0"/>
+          <a:chOff x="0" y="0"/>
+          <a:chExt cx="0" cy="0"/>
+        </a:xfrm>
+      </p:grpSpPr>
+      <p:sp>
+        <p:nvSpPr>
+          <p:cNvPr id="2" name="Slide Image Placeholder 1"/>
+          <p:cNvSpPr>
+            <a:spLocks noGrp="1" noRot="1" noChangeAspect="1"/>
+          </p:cNvSpPr>
+          <p:nvPr>
+            <p:ph type="sldImg"/>
+          </p:nvPr>
+        </p:nvSpPr>
+        <p:spPr/>
+      </p:sp>
+      <p:sp>
+        <p:nvSpPr>
+          <p:cNvPr id="3" name="Notes Placeholder 2"/>
+          <p:cNvSpPr>
+            <a:spLocks noGrp="1"/>
+          </p:cNvSpPr>
+          <p:nvPr>
+            <p:ph type="body" idx="1"/>
+          </p:nvPr>
+        </p:nvSpPr>
+        <p:spPr/>
+        <p:txBody>
+          <a:bodyPr/>
+          <a:lstStyle/>
+          <a:p>
+            <a:r>
+              <a:rPr lang="en-US" dirty="0"/>
+              <a:t>I complete the second page of the logbook: the matter taught, the evaluation, the homework and the attendance.</a:t>
+            </a:r>
+            <a:endParaRPr lang="en-US" dirty="0"/>
+          </a:p>
+        </p:txBody>
+      </p:sp>
+      <p:sp>
+        <p:nvSpPr>
+          <p:cNvPr id="4" name="Slide Number Placeholder 3"/>
+          <p:cNvSpPr>
+            <a:spLocks noGrp="1"/>
+          </p:cNvSpPr>
+          <p:nvPr>
+            <p:ph type="sldNum" sz="quarter" idx="10"/>
+          </p:nvPr>
+        </p:nvSpPr>
+        <p:spPr/>
+        <p:txBody>
+          <a:bodyPr/>
+          <a:lstStyle/>
+          <a:p>
+            <a:fld id="{F7021451-1387-4CA6-816F-3879F97B5CBC}" type="slidenum">
+              <a:rPr lang="en-US"/>
+              <a:t>46</a:t>
+            </a:fld>
+            <a:endParaRPr lang="en-US"/>
+          </a:p>
+        </p:txBody>
+      </p:sp>
+    </p:spTree>
+    <p:extLst>
+      <p:ext uri="{BB962C8B-B14F-4D97-AF65-F5344CB8AC3E}">
+        <p14:creationId xmlns:p14="http://schemas.microsoft.com/office/powerpoint/2010/main" val="1024086991"/>
+      </p:ext>
+    </p:extLst>
+  </p:cSld>
+  <p:clrMapOvr>
+    <a:masterClrMapping/>
+  </p:clrMapOvr>
+</p:notes>
+</file>
+
+<file path=ppt/notesSlides/notesSlide47.xml><?xml version="1.0" encoding="utf-8"?>
+<p:notes xmlns:a="http://schemas.openxmlformats.org/drawingml/2006/main" xmlns:r="http://schemas.openxmlformats.org/officeDocument/2006/relationships" xmlns:p="http://schemas.openxmlformats.org/presentationml/2006/main">
+  <p:cSld>
+    <p:spTree>
+      <p:nvGrpSpPr>
+        <p:cNvPr id="1" name=""/>
+        <p:cNvGrpSpPr/>
+        <p:nvPr/>
+      </p:nvGrpSpPr>
+      <p:grpSpPr>
+        <a:xfrm>
+          <a:off x="0" y="0"/>
+          <a:ext cx="0" cy="0"/>
+          <a:chOff x="0" y="0"/>
+          <a:chExt cx="0" cy="0"/>
+        </a:xfrm>
+      </p:grpSpPr>
+      <p:sp>
+        <p:nvSpPr>
+          <p:cNvPr id="2" name="Slide Image Placeholder 1"/>
+          <p:cNvSpPr>
+            <a:spLocks noGrp="1" noRot="1" noChangeAspect="1"/>
+          </p:cNvSpPr>
+          <p:nvPr>
+            <p:ph type="sldImg"/>
+          </p:nvPr>
+        </p:nvSpPr>
+        <p:spPr/>
+      </p:sp>
+      <p:sp>
+        <p:nvSpPr>
+          <p:cNvPr id="3" name="Notes Placeholder 2"/>
+          <p:cNvSpPr>
+            <a:spLocks noGrp="1"/>
+          </p:cNvSpPr>
+          <p:nvPr>
+            <p:ph type="body" idx="1"/>
+          </p:nvPr>
+        </p:nvSpPr>
+        <p:spPr/>
+        <p:txBody>
+          <a:bodyPr/>
+          <a:lstStyle/>
+          <a:p>
+            <a:r>
+              <a:rPr lang="en-US" dirty="0"/>
+              <a:t>This slide is for me, the teacher: it gives the timing of the lesson and what to do if the projector is not available.</a:t>
+            </a:r>
+            <a:endParaRPr lang="en-US" dirty="0"/>
+          </a:p>
+        </p:txBody>
+      </p:sp>
+      <p:sp>
+        <p:nvSpPr>
+          <p:cNvPr id="4" name="Slide Number Placeholder 3"/>
+          <p:cNvSpPr>
+            <a:spLocks noGrp="1"/>
+          </p:cNvSpPr>
+          <p:nvPr>
+            <p:ph type="sldNum" sz="quarter" idx="10"/>
+          </p:nvPr>
+        </p:nvSpPr>
+        <p:spPr/>
+        <p:txBody>
+          <a:bodyPr/>
+          <a:lstStyle/>
+          <a:p>
+            <a:fld id="{F7021451-1387-4CA6-816F-3879F97B5CBC}" type="slidenum">
+              <a:rPr lang="en-US"/>
+              <a:t>47</a:t>
+            </a:fld>
+            <a:endParaRPr lang="en-US"/>
+          </a:p>
+        </p:txBody>
+      </p:sp>
+    </p:spTree>
+    <p:extLst>
+      <p:ext uri="{BB962C8B-B14F-4D97-AF65-F5344CB8AC3E}">
+        <p14:creationId xmlns:p14="http://schemas.microsoft.com/office/powerpoint/2010/main" val="1024086991"/>
+      </p:ext>
+    </p:extLst>
+  </p:cSld>
+  <p:clrMapOvr>
+    <a:masterClrMapping/>
+  </p:clrMapOvr>
+</p:notes>
+</file>
+
+<file path=ppt/notesSlides/notesSlide48.xml><?xml version="1.0" encoding="utf-8"?>
+<p:notes xmlns:a="http://schemas.openxmlformats.org/drawingml/2006/main" xmlns:r="http://schemas.openxmlformats.org/officeDocument/2006/relationships" xmlns:p="http://schemas.openxmlformats.org/presentationml/2006/main">
+  <p:cSld>
+    <p:spTree>
+      <p:nvGrpSpPr>
+        <p:cNvPr id="1" name=""/>
+        <p:cNvGrpSpPr/>
+        <p:nvPr/>
+      </p:nvGrpSpPr>
+      <p:grpSpPr>
+        <a:xfrm>
+          <a:off x="0" y="0"/>
+          <a:ext cx="0" cy="0"/>
+          <a:chOff x="0" y="0"/>
+          <a:chExt cx="0" cy="0"/>
+        </a:xfrm>
+      </p:grpSpPr>
+      <p:sp>
+        <p:nvSpPr>
+          <p:cNvPr id="2" name="Slide Image Placeholder 1"/>
+          <p:cNvSpPr>
+            <a:spLocks noGrp="1" noRot="1" noChangeAspect="1"/>
+          </p:cNvSpPr>
+          <p:nvPr>
+            <p:ph type="sldImg"/>
+          </p:nvPr>
+        </p:nvSpPr>
+        <p:spPr/>
+      </p:sp>
+      <p:sp>
+        <p:nvSpPr>
+          <p:cNvPr id="3" name="Notes Placeholder 2"/>
+          <p:cNvSpPr>
+            <a:spLocks noGrp="1"/>
+          </p:cNvSpPr>
+          <p:nvPr>
+            <p:ph type="body" idx="1"/>
+          </p:nvPr>
+        </p:nvSpPr>
+        <p:spPr/>
+        <p:txBody>
+          <a:bodyPr/>
+          <a:lstStyle/>
+          <a:p>
+            <a:r>
+              <a:rPr lang="en-US" dirty="0"/>
+              <a:t>These are the references and picture credits used to prepare this lesson.</a:t>
+            </a:r>
+            <a:endParaRPr lang="en-US" dirty="0"/>
+          </a:p>
+        </p:txBody>
+      </p:sp>
+      <p:sp>
+        <p:nvSpPr>
+          <p:cNvPr id="4" name="Slide Number Placeholder 3"/>
+          <p:cNvSpPr>
+            <a:spLocks noGrp="1"/>
+          </p:cNvSpPr>
+          <p:nvPr>
+            <p:ph type="sldNum" sz="quarter" idx="10"/>
+          </p:nvPr>
+        </p:nvSpPr>
+        <p:spPr/>
+        <p:txBody>
+          <a:bodyPr/>
+          <a:lstStyle/>
+          <a:p>
+            <a:fld id="{F7021451-1387-4CA6-816F-3879F97B5CBC}" type="slidenum">
+              <a:rPr lang="en-US"/>
+              <a:t>48</a:t>
             </a:fld>
             <a:endParaRPr lang="en-US"/>
           </a:p>
@@ -4418,7 +4685,7 @@
           <a:p>
             <a:r>
               <a:rPr lang="en-US" dirty="0"/>
-              <a:t>Listen carefully to this situation from real life. After a heavy storm in Garoua, Halima sees a small channel cut in the red soil beside the road. The water carried sand and stones and dropped them lower down. Think about it, because I am going to ask you some questions.</a:t>
+              <a:t>Listen carefully to this situation from real life. After a heavy storm in Garoua, Halima sees a small channel cut in the red soil beside the road. The water has carried sand and stones and dropped them lower down. She asks: "How is the land worn down like this, and what forces do it?" Think about it, because I am going to ask you some questions.</a:t>
             </a:r>
             <a:endParaRPr lang="en-US" dirty="0"/>
           </a:p>
@@ -6101,7 +6368,7 @@
                 <a:ea typeface="Times New Roman" pitchFamily="34" charset="-122"/>
                 <a:cs typeface="Times New Roman" pitchFamily="34" charset="-120"/>
               </a:rPr>
-              <a:t>Halima does not know how water changes the land.</a:t>
+              <a:t>Halima does not know how the land is worn down and by which forces.</a:t>
             </a:r>
             <a:endParaRPr lang="en-US" sz="4000" dirty="0"/>
           </a:p>
@@ -6320,7 +6587,7 @@
                 <a:ea typeface="Times New Roman" pitchFamily="34" charset="-122"/>
                 <a:cs typeface="Times New Roman" pitchFamily="34" charset="-120"/>
               </a:rPr>
-              <a:t>What did the water do?</a:t>
+              <a:t>What did the water carry?</a:t>
             </a:r>
             <a:endParaRPr lang="en-US" sz="4000" dirty="0"/>
           </a:p>
@@ -6539,7 +6806,7 @@
                 <a:ea typeface="Times New Roman" pitchFamily="34" charset="-122"/>
                 <a:cs typeface="Times New Roman" pitchFamily="34" charset="-120"/>
               </a:rPr>
-              <a:t>It cut a channel, carried sand and stones, and dropped them.</a:t>
+              <a:t>Sand and stones.</a:t>
             </a:r>
             <a:endParaRPr lang="en-US" sz="4000" dirty="0"/>
           </a:p>
@@ -6758,7 +7025,7 @@
                 <a:ea typeface="Times New Roman" pitchFamily="34" charset="-122"/>
                 <a:cs typeface="Times New Roman" pitchFamily="34" charset="-120"/>
               </a:rPr>
-              <a:t>What do we call this wearing down of the land?</a:t>
+              <a:t>Which force wore away the soil here?</a:t>
             </a:r>
             <a:endParaRPr lang="en-US" sz="4000" dirty="0"/>
           </a:p>
@@ -6977,7 +7244,7 @@
                 <a:ea typeface="Times New Roman" pitchFamily="34" charset="-122"/>
                 <a:cs typeface="Times New Roman" pitchFamily="34" charset="-120"/>
               </a:rPr>
-              <a:t>Denudation.</a:t>
+              <a:t>Running water (rain water).</a:t>
             </a:r>
             <a:endParaRPr lang="en-US" sz="4000" dirty="0"/>
           </a:p>
@@ -7527,7 +7794,7 @@
                 <a:ea typeface="Calibri" pitchFamily="34" charset="-122"/>
                 <a:cs typeface="Calibri" pitchFamily="34" charset="-120"/>
               </a:rPr>
-              <a:t>1. MEANING OF DENUDATION</a:t>
+              <a:t>1. PROCESSES OF DENUDATION</a:t>
             </a:r>
             <a:endParaRPr lang="en-US" sz="1400" dirty="0"/>
           </a:p>
@@ -7629,7 +7896,7 @@
                 <a:ea typeface="Times New Roman" pitchFamily="34" charset="-122"/>
                 <a:cs typeface="Times New Roman" pitchFamily="34" charset="-120"/>
               </a:rPr>
-              <a:t>A channel cut by rain water in red soil.</a:t>
+              <a:t>A channel cut by rain water.</a:t>
             </a:r>
             <a:endParaRPr lang="en-US" sz="1800" dirty="0"/>
           </a:p>
@@ -7741,7 +8008,7 @@
                 <a:ea typeface="Calibri" pitchFamily="34" charset="-122"/>
                 <a:cs typeface="Calibri" pitchFamily="34" charset="-120"/>
               </a:rPr>
-              <a:t>1. MEANING OF DENUDATION</a:t>
+              <a:t>1. PROCESSES OF DENUDATION</a:t>
             </a:r>
             <a:endParaRPr lang="en-US" sz="1400" dirty="0"/>
           </a:p>
@@ -8555,7 +8822,7 @@
                 <a:ea typeface="Calibri" pitchFamily="34" charset="-122"/>
                 <a:cs typeface="Calibri" pitchFamily="34" charset="-120"/>
               </a:rPr>
-              <a:t>1. MEANING OF DENUDATION</a:t>
+              <a:t>1. PROCESSES OF DENUDATION</a:t>
             </a:r>
             <a:endParaRPr lang="en-US" sz="1400" dirty="0"/>
           </a:p>
@@ -8774,7 +9041,7 @@
                 <a:ea typeface="Calibri" pitchFamily="34" charset="-122"/>
                 <a:cs typeface="Calibri" pitchFamily="34" charset="-120"/>
               </a:rPr>
-              <a:t>2. PROCESSES OF DENUDATION</a:t>
+              <a:t>1. PROCESSES OF DENUDATION</a:t>
             </a:r>
             <a:endParaRPr lang="en-US" sz="1400" dirty="0"/>
           </a:p>
@@ -8876,7 +9143,7 @@
                 <a:ea typeface="Times New Roman" pitchFamily="34" charset="-122"/>
                 <a:cs typeface="Times New Roman" pitchFamily="34" charset="-120"/>
               </a:rPr>
-              <a:t>Animation: the four processes of denudation.</a:t>
+              <a:t>Animation: the processes of denudation.</a:t>
             </a:r>
             <a:endParaRPr lang="en-US" sz="1800" dirty="0"/>
           </a:p>
@@ -8988,7 +9255,7 @@
                 <a:ea typeface="Calibri" pitchFamily="34" charset="-122"/>
                 <a:cs typeface="Calibri" pitchFamily="34" charset="-120"/>
               </a:rPr>
-              <a:t>2. PROCESSES OF DENUDATION</a:t>
+              <a:t>1. PROCESSES OF DENUDATION</a:t>
             </a:r>
             <a:endParaRPr lang="en-US" sz="1400" dirty="0"/>
           </a:p>
@@ -9095,7 +9362,7 @@
                 <a:ea typeface="Times New Roman" pitchFamily="34" charset="-122"/>
                 <a:cs typeface="Times New Roman" pitchFamily="34" charset="-120"/>
               </a:rPr>
-              <a:t>Name the four processes in the right order.</a:t>
+              <a:t>What happens to the rock before it can be carried away?</a:t>
             </a:r>
             <a:endParaRPr lang="en-US" sz="4000" dirty="0"/>
           </a:p>
@@ -9207,7 +9474,7 @@
                 <a:ea typeface="Calibri" pitchFamily="34" charset="-122"/>
                 <a:cs typeface="Calibri" pitchFamily="34" charset="-120"/>
               </a:rPr>
-              <a:t>2. PROCESSES OF DENUDATION</a:t>
+              <a:t>1. PROCESSES OF DENUDATION</a:t>
             </a:r>
             <a:endParaRPr lang="en-US" sz="1400" dirty="0"/>
           </a:p>
@@ -9314,7 +9581,7 @@
                 <a:ea typeface="Times New Roman" pitchFamily="34" charset="-122"/>
                 <a:cs typeface="Times New Roman" pitchFamily="34" charset="-120"/>
               </a:rPr>
-              <a:t>Weathering, erosion, transport, deposition.</a:t>
+              <a:t>It is broken down in its place: this is weathering.</a:t>
             </a:r>
             <a:endParaRPr lang="en-US" sz="4000" dirty="0"/>
           </a:p>
@@ -9426,7 +9693,7 @@
                 <a:ea typeface="Calibri" pitchFamily="34" charset="-122"/>
                 <a:cs typeface="Calibri" pitchFamily="34" charset="-120"/>
               </a:rPr>
-              <a:t>3. AGENTS OF DENUDATION</a:t>
+              <a:t>2. AGENTS OF DENUDATION</a:t>
             </a:r>
             <a:endParaRPr lang="en-US" sz="1400" dirty="0"/>
           </a:p>
@@ -9528,7 +9795,7 @@
                 <a:ea typeface="Times New Roman" pitchFamily="34" charset="-122"/>
                 <a:cs typeface="Times New Roman" pitchFamily="34" charset="-120"/>
               </a:rPr>
-              <a:t>A muddy river seen from space.</a:t>
+              <a:t>A muddy river.</a:t>
             </a:r>
             <a:endParaRPr lang="en-US" sz="1800" dirty="0"/>
           </a:p>
@@ -9640,7 +9907,7 @@
                 <a:ea typeface="Calibri" pitchFamily="34" charset="-122"/>
                 <a:cs typeface="Calibri" pitchFamily="34" charset="-120"/>
               </a:rPr>
-              <a:t>3. AGENTS OF DENUDATION</a:t>
+              <a:t>2. AGENTS OF DENUDATION</a:t>
             </a:r>
             <a:endParaRPr lang="en-US" sz="1400" dirty="0"/>
           </a:p>
@@ -9705,7 +9972,7 @@
                 <a:ea typeface="Times New Roman" pitchFamily="34" charset="-122"/>
                 <a:cs typeface="Times New Roman" pitchFamily="34" charset="-120"/>
               </a:rPr>
-              <a:t>Activity 3: Question</a:t>
+              <a:t>Activity 3: Question 1</a:t>
             </a:r>
             <a:endParaRPr lang="en-US" sz="3600" dirty="0"/>
           </a:p>
@@ -9747,7 +10014,7 @@
                 <a:ea typeface="Times New Roman" pitchFamily="34" charset="-122"/>
                 <a:cs typeface="Times New Roman" pitchFamily="34" charset="-120"/>
               </a:rPr>
-              <a:t>Which agent carries the mud? Name two other agents.</a:t>
+              <a:t>Which agent carries this mud?</a:t>
             </a:r>
             <a:endParaRPr lang="en-US" sz="4000" dirty="0"/>
           </a:p>
@@ -9859,7 +10126,7 @@
                 <a:ea typeface="Calibri" pitchFamily="34" charset="-122"/>
                 <a:cs typeface="Calibri" pitchFamily="34" charset="-120"/>
               </a:rPr>
-              <a:t>3. AGENTS OF DENUDATION</a:t>
+              <a:t>2. AGENTS OF DENUDATION</a:t>
             </a:r>
             <a:endParaRPr lang="en-US" sz="1400" dirty="0"/>
           </a:p>
@@ -9924,7 +10191,7 @@
                 <a:ea typeface="Times New Roman" pitchFamily="34" charset="-122"/>
                 <a:cs typeface="Times New Roman" pitchFamily="34" charset="-120"/>
               </a:rPr>
-              <a:t>Activity 3: Answer</a:t>
+              <a:t>Activity 3: Answer 1</a:t>
             </a:r>
             <a:endParaRPr lang="en-US" sz="3600" dirty="0"/>
           </a:p>
@@ -9966,7 +10233,7 @@
                 <a:ea typeface="Times New Roman" pitchFamily="34" charset="-122"/>
                 <a:cs typeface="Times New Roman" pitchFamily="34" charset="-120"/>
               </a:rPr>
-              <a:t>Running water. Others: wind, waves, ice.</a:t>
+              <a:t>Running water.</a:t>
             </a:r>
             <a:endParaRPr lang="en-US" sz="4000" dirty="0"/>
           </a:p>
@@ -10078,7 +10345,7 @@
                 <a:ea typeface="Calibri" pitchFamily="34" charset="-122"/>
                 <a:cs typeface="Calibri" pitchFamily="34" charset="-120"/>
               </a:rPr>
-              <a:t>BOARD SUMMARY</a:t>
+              <a:t>2. AGENTS OF DENUDATION</a:t>
             </a:r>
             <a:endParaRPr lang="en-US" sz="1400" dirty="0"/>
           </a:p>
@@ -10143,7 +10410,7 @@
                 <a:ea typeface="Times New Roman" pitchFamily="34" charset="-122"/>
                 <a:cs typeface="Times New Roman" pitchFamily="34" charset="-120"/>
               </a:rPr>
-              <a:t>Board Summary</a:t>
+              <a:t>Activity 3: Question 2</a:t>
             </a:r>
             <a:endParaRPr lang="en-US" sz="3600" dirty="0"/>
           </a:p>
@@ -10177,7 +10444,7 @@
               <a:buNone/>
             </a:pPr>
             <a:r>
-              <a:rPr lang="en-US" sz="4000" b="1" dirty="0">
+              <a:rPr lang="en-US" sz="4000" dirty="0">
                 <a:solidFill>
                   <a:srgbClr val="111111"/>
                 </a:solidFill>
@@ -10185,47 +10452,7 @@
                 <a:ea typeface="Times New Roman" pitchFamily="34" charset="-122"/>
                 <a:cs typeface="Times New Roman" pitchFamily="34" charset="-120"/>
               </a:rPr>
-              <a:t>Topic: Denudation Processes, Landforms and Impacts on Man</a:t>
-            </a:r>
-            <a:endParaRPr lang="en-US" sz="4000" dirty="0"/>
-          </a:p>
-          <a:p>
-            <a:pPr algn="l" indent="0" marL="0">
-              <a:spcAft>
-                <a:spcPts val="800"/>
-              </a:spcAft>
-              <a:buNone/>
-            </a:pPr>
-            <a:r>
-              <a:rPr lang="en-US" sz="4000" b="1" dirty="0">
-                <a:solidFill>
-                  <a:srgbClr val="111111"/>
-                </a:solidFill>
-                <a:latin typeface="Times New Roman" pitchFamily="34" charset="0"/>
-                <a:ea typeface="Times New Roman" pitchFamily="34" charset="-122"/>
-                <a:cs typeface="Times New Roman" pitchFamily="34" charset="-120"/>
-              </a:rPr>
-              <a:t>Sub-topic: Weathering Processes and Impacts on Man</a:t>
-            </a:r>
-            <a:endParaRPr lang="en-US" sz="4000" dirty="0"/>
-          </a:p>
-          <a:p>
-            <a:pPr algn="l" indent="0" marL="0">
-              <a:spcAft>
-                <a:spcPts val="800"/>
-              </a:spcAft>
-              <a:buNone/>
-            </a:pPr>
-            <a:r>
-              <a:rPr lang="en-US" sz="4000" b="1" dirty="0">
-                <a:solidFill>
-                  <a:srgbClr val="990011"/>
-                </a:solidFill>
-                <a:latin typeface="Times New Roman" pitchFamily="34" charset="0"/>
-                <a:ea typeface="Times New Roman" pitchFamily="34" charset="-122"/>
-                <a:cs typeface="Times New Roman" pitchFamily="34" charset="-120"/>
-              </a:rPr>
-              <a:t>Lesson 14: Denudation</a:t>
+              <a:t>Name another agent of denudation.</a:t>
             </a:r>
             <a:endParaRPr lang="en-US" sz="4000" dirty="0"/>
           </a:p>
@@ -10337,7 +10564,7 @@
                 <a:ea typeface="Calibri" pitchFamily="34" charset="-122"/>
                 <a:cs typeface="Calibri" pitchFamily="34" charset="-120"/>
               </a:rPr>
-              <a:t>BOARD SUMMARY</a:t>
+              <a:t>2. AGENTS OF DENUDATION</a:t>
             </a:r>
             <a:endParaRPr lang="en-US" sz="1400" dirty="0"/>
           </a:p>
@@ -10402,7 +10629,7 @@
                 <a:ea typeface="Times New Roman" pitchFamily="34" charset="-122"/>
                 <a:cs typeface="Times New Roman" pitchFamily="34" charset="-120"/>
               </a:rPr>
-              <a:t>1. Meaning of Denudation</a:t>
+              <a:t>Activity 3: Answer 2</a:t>
             </a:r>
             <a:endParaRPr lang="en-US" sz="3600" dirty="0"/>
           </a:p>
@@ -10436,7 +10663,7 @@
               <a:buNone/>
             </a:pPr>
             <a:r>
-              <a:rPr lang="en-US" sz="4000" i="1" dirty="0">
+              <a:rPr lang="en-US" sz="4000" dirty="0">
                 <a:solidFill>
                   <a:srgbClr val="111111"/>
                 </a:solidFill>
@@ -10444,44 +10671,7 @@
                 <a:ea typeface="Times New Roman" pitchFamily="34" charset="-122"/>
                 <a:cs typeface="Times New Roman" pitchFamily="34" charset="-120"/>
               </a:rPr>
-              <a:t>Denudation is defined as follows:</a:t>
-            </a:r>
-            <a:endParaRPr lang="en-US" sz="4000" dirty="0"/>
-          </a:p>
-          <a:p>
-            <a:pPr algn="l" indent="0" marL="0">
-              <a:spcAft>
-                <a:spcPts val="800"/>
-              </a:spcAft>
-              <a:buNone/>
-            </a:pPr>
-            <a:r>
-              <a:rPr lang="en-US" sz="4000" b="1" dirty="0">
-                <a:solidFill>
-                  <a:srgbClr val="111111"/>
-                </a:solidFill>
-                <a:latin typeface="Times New Roman" pitchFamily="34" charset="0"/>
-                <a:ea typeface="Times New Roman" pitchFamily="34" charset="-122"/>
-                <a:cs typeface="Times New Roman" pitchFamily="34" charset="-120"/>
-              </a:rPr>
-              <a:t>Denudation: </a:t>
-            </a:r>
-            <a:pPr algn="l" indent="0" marL="0">
-              <a:spcAft>
-                <a:spcPts val="800"/>
-              </a:spcAft>
-              <a:buNone/>
-            </a:pPr>
-            <a:r>
-              <a:rPr lang="en-US" sz="4000" dirty="0">
-                <a:solidFill>
-                  <a:srgbClr val="111111"/>
-                </a:solidFill>
-                <a:latin typeface="Times New Roman" pitchFamily="34" charset="0"/>
-                <a:ea typeface="Times New Roman" pitchFamily="34" charset="-122"/>
-                <a:cs typeface="Times New Roman" pitchFamily="34" charset="-120"/>
-              </a:rPr>
-              <a:t>It is the general wearing down and lowering of the land surface.</a:t>
+              <a:t>Wind (or waves).</a:t>
             </a:r>
             <a:endParaRPr lang="en-US" sz="4000" dirty="0"/>
           </a:p>
@@ -10616,7 +10806,7 @@
         <p:spPr>
           <a:xfrm>
             <a:off x="0" y="658368"/>
-            <a:ext cx="3840480" cy="5833872"/>
+            <a:ext cx="5120640" cy="5833872"/>
           </a:xfrm>
           <a:prstGeom prst="rect">
             <a:avLst/>
@@ -10631,8 +10821,8 @@
         </p:nvSpPr>
         <p:spPr>
           <a:xfrm>
-            <a:off x="4069080" y="1005840"/>
-            <a:ext cx="7802575" cy="731520"/>
+            <a:off x="5349240" y="1005840"/>
+            <a:ext cx="6522415" cy="731520"/>
           </a:xfrm>
           <a:prstGeom prst="rect">
             <a:avLst/>
@@ -10658,7 +10848,7 @@
                 <a:ea typeface="Times New Roman" pitchFamily="34" charset="-122"/>
                 <a:cs typeface="Times New Roman" pitchFamily="34" charset="-120"/>
               </a:rPr>
-              <a:t>2. Processes of Denudation</a:t>
+              <a:t>Board Summary</a:t>
             </a:r>
             <a:endParaRPr lang="en-US" sz="3600" dirty="0"/>
           </a:p>
@@ -10672,8 +10862,8 @@
         </p:nvSpPr>
         <p:spPr>
           <a:xfrm>
-            <a:off x="4069080" y="1783080"/>
-            <a:ext cx="7802575" cy="4663440"/>
+            <a:off x="5349240" y="1783080"/>
+            <a:ext cx="6522415" cy="4663440"/>
           </a:xfrm>
           <a:prstGeom prst="rect">
             <a:avLst/>
@@ -10692,7 +10882,7 @@
               <a:buNone/>
             </a:pPr>
             <a:r>
-              <a:rPr lang="en-US" sz="4000" i="1" dirty="0">
+              <a:rPr lang="en-US" sz="4000" b="1" dirty="0">
                 <a:solidFill>
                   <a:srgbClr val="111111"/>
                 </a:solidFill>
@@ -10700,7 +10890,7 @@
                 <a:ea typeface="Times New Roman" pitchFamily="34" charset="-122"/>
                 <a:cs typeface="Times New Roman" pitchFamily="34" charset="-120"/>
               </a:rPr>
-              <a:t>Denudation takes place through the following processes:</a:t>
+              <a:t>Topic: Denudation Processes, Landforms and Impacts on Man</a:t>
             </a:r>
             <a:endParaRPr lang="en-US" sz="4000" dirty="0"/>
           </a:p>
@@ -10720,8 +10910,11 @@
                 <a:ea typeface="Times New Roman" pitchFamily="34" charset="-122"/>
                 <a:cs typeface="Times New Roman" pitchFamily="34" charset="-120"/>
               </a:rPr>
-              <a:t>Weathering: </a:t>
-            </a:r>
+              <a:t>Sub-topic: Weathering Processes and Impacts on Man</a:t>
+            </a:r>
+            <a:endParaRPr lang="en-US" sz="4000" dirty="0"/>
+          </a:p>
+          <a:p>
             <a:pPr algn="l" indent="0" marL="0">
               <a:spcAft>
                 <a:spcPts val="800"/>
@@ -10729,52 +10922,15 @@
               <a:buNone/>
             </a:pPr>
             <a:r>
-              <a:rPr lang="en-US" sz="4000" dirty="0">
-                <a:solidFill>
-                  <a:srgbClr val="111111"/>
+              <a:rPr lang="en-US" sz="4000" b="1" dirty="0">
+                <a:solidFill>
+                  <a:srgbClr val="990011"/>
                 </a:solidFill>
                 <a:latin typeface="Times New Roman" pitchFamily="34" charset="0"/>
                 <a:ea typeface="Times New Roman" pitchFamily="34" charset="-122"/>
                 <a:cs typeface="Times New Roman" pitchFamily="34" charset="-120"/>
               </a:rPr>
-              <a:t>It is the breaking down of rocks in their place.</a:t>
-            </a:r>
-            <a:endParaRPr lang="en-US" sz="4000" dirty="0"/>
-          </a:p>
-          <a:p>
-            <a:pPr algn="l" indent="0" marL="0">
-              <a:spcAft>
-                <a:spcPts val="800"/>
-              </a:spcAft>
-              <a:buNone/>
-            </a:pPr>
-            <a:r>
-              <a:rPr lang="en-US" sz="4000" b="1" dirty="0">
-                <a:solidFill>
-                  <a:srgbClr val="111111"/>
-                </a:solidFill>
-                <a:latin typeface="Times New Roman" pitchFamily="34" charset="0"/>
-                <a:ea typeface="Times New Roman" pitchFamily="34" charset="-122"/>
-                <a:cs typeface="Times New Roman" pitchFamily="34" charset="-120"/>
-              </a:rPr>
-              <a:t>Erosion: </a:t>
-            </a:r>
-            <a:pPr algn="l" indent="0" marL="0">
-              <a:spcAft>
-                <a:spcPts val="800"/>
-              </a:spcAft>
-              <a:buNone/>
-            </a:pPr>
-            <a:r>
-              <a:rPr lang="en-US" sz="4000" dirty="0">
-                <a:solidFill>
-                  <a:srgbClr val="111111"/>
-                </a:solidFill>
-                <a:latin typeface="Times New Roman" pitchFamily="34" charset="0"/>
-                <a:ea typeface="Times New Roman" pitchFamily="34" charset="-122"/>
-                <a:cs typeface="Times New Roman" pitchFamily="34" charset="-120"/>
-              </a:rPr>
-              <a:t>It is the wearing away and picking up of rock and soil by an agent.</a:t>
+              <a:t>Lesson 14: Denudation</a:t>
             </a:r>
             <a:endParaRPr lang="en-US" sz="4000" dirty="0"/>
           </a:p>
@@ -11960,7 +12116,7 @@
                 <a:ea typeface="Times New Roman" pitchFamily="34" charset="-122"/>
                 <a:cs typeface="Times New Roman" pitchFamily="34" charset="-120"/>
               </a:rPr>
-              <a:t>2. Processes of Denudation (continued)</a:t>
+              <a:t>DEFINITIONS</a:t>
             </a:r>
             <a:endParaRPr lang="en-US" sz="3600" dirty="0"/>
           </a:p>
@@ -11994,7 +12150,7 @@
               <a:buNone/>
             </a:pPr>
             <a:r>
-              <a:rPr lang="en-US" sz="4000" b="1" dirty="0">
+              <a:rPr lang="en-US" sz="4000" i="1" dirty="0">
                 <a:solidFill>
                   <a:srgbClr val="111111"/>
                 </a:solidFill>
@@ -12002,8 +12158,11 @@
                 <a:ea typeface="Times New Roman" pitchFamily="34" charset="-122"/>
                 <a:cs typeface="Times New Roman" pitchFamily="34" charset="-120"/>
               </a:rPr>
-              <a:t>Transportation: </a:t>
-            </a:r>
+              <a:t>The key terms of this lesson are defined as follows:</a:t>
+            </a:r>
+            <a:endParaRPr lang="en-US" sz="4000" dirty="0"/>
+          </a:p>
+          <a:p>
             <a:pPr algn="l" indent="0" marL="0">
               <a:spcAft>
                 <a:spcPts val="800"/>
@@ -12011,7 +12170,7 @@
               <a:buNone/>
             </a:pPr>
             <a:r>
-              <a:rPr lang="en-US" sz="4000" dirty="0">
+              <a:rPr lang="en-US" sz="4000" b="1" dirty="0">
                 <a:solidFill>
                   <a:srgbClr val="111111"/>
                 </a:solidFill>
@@ -12019,11 +12178,8 @@
                 <a:ea typeface="Times New Roman" pitchFamily="34" charset="-122"/>
                 <a:cs typeface="Times New Roman" pitchFamily="34" charset="-120"/>
               </a:rPr>
-              <a:t>It is the carrying away of the eroded material.</a:t>
-            </a:r>
-            <a:endParaRPr lang="en-US" sz="4000" dirty="0"/>
-          </a:p>
-          <a:p>
+              <a:t>Denudation: </a:t>
+            </a:r>
             <a:pPr algn="l" indent="0" marL="0">
               <a:spcAft>
                 <a:spcPts val="800"/>
@@ -12031,7 +12187,7 @@
               <a:buNone/>
             </a:pPr>
             <a:r>
-              <a:rPr lang="en-US" sz="4000" b="1" dirty="0">
+              <a:rPr lang="en-US" sz="4000" dirty="0">
                 <a:solidFill>
                   <a:srgbClr val="111111"/>
                 </a:solidFill>
@@ -12039,24 +12195,7 @@
                 <a:ea typeface="Times New Roman" pitchFamily="34" charset="-122"/>
                 <a:cs typeface="Times New Roman" pitchFamily="34" charset="-120"/>
               </a:rPr>
-              <a:t>Deposition: </a:t>
-            </a:r>
-            <a:pPr algn="l" indent="0" marL="0">
-              <a:spcAft>
-                <a:spcPts val="800"/>
-              </a:spcAft>
-              <a:buNone/>
-            </a:pPr>
-            <a:r>
-              <a:rPr lang="en-US" sz="4000" dirty="0">
-                <a:solidFill>
-                  <a:srgbClr val="111111"/>
-                </a:solidFill>
-                <a:latin typeface="Times New Roman" pitchFamily="34" charset="0"/>
-                <a:ea typeface="Times New Roman" pitchFamily="34" charset="-122"/>
-                <a:cs typeface="Times New Roman" pitchFamily="34" charset="-120"/>
-              </a:rPr>
-              <a:t>It is the dropping of the material when the agent loses energy.</a:t>
+              <a:t>It is the general wearing down and lowering of the land surface by natural forces.</a:t>
             </a:r>
             <a:endParaRPr lang="en-US" sz="4000" dirty="0"/>
           </a:p>
@@ -12174,48 +12313,9 @@
           </a:p>
         </p:txBody>
       </p:sp>
-      <p:sp>
-        <p:nvSpPr>
-          <p:cNvPr id="3" name="Text 1"/>
-          <p:cNvSpPr/>
-          <p:nvPr/>
-        </p:nvSpPr>
-        <p:spPr>
-          <a:xfrm>
-            <a:off x="457200" y="1005840"/>
-            <a:ext cx="11277295" cy="731520"/>
-          </a:xfrm>
-          <a:prstGeom prst="rect">
-            <a:avLst/>
-          </a:prstGeom>
-          <a:noFill/>
-          <a:ln/>
-        </p:spPr>
-        <p:txBody>
-          <a:bodyPr wrap="square" lIns="0" tIns="0" rIns="0" bIns="0" rtlCol="0" anchor="ctr"/>
-          <a:lstStyle/>
-          <a:p>
-            <a:pPr algn="ctr" indent="0" marL="0">
-              <a:buNone/>
-            </a:pPr>
-            <a:r>
-              <a:rPr lang="en-US" sz="3600" b="1" dirty="0">
-                <a:solidFill>
-                  <a:srgbClr val="990011"/>
-                </a:solidFill>
-                <a:latin typeface="Times New Roman" pitchFamily="34" charset="0"/>
-                <a:ea typeface="Times New Roman" pitchFamily="34" charset="-122"/>
-                <a:cs typeface="Times New Roman" pitchFamily="34" charset="-120"/>
-              </a:rPr>
-              <a:t>2. Processes of Denudation</a:t>
-            </a:r>
-            <a:endParaRPr lang="en-US" sz="3600" dirty="0"/>
-          </a:p>
-        </p:txBody>
-      </p:sp>
       <p:pic>
         <p:nvPicPr>
-          <p:cNvPr id="4" name="Image 0" descr="/home/claude/f4/img/v2/denudation_last.png">    </p:cNvPr>
+          <p:cNvPr id="3" name="Image 0" descr="/home/claude/f4/img/minesec_sheet.png">    </p:cNvPr>
           <p:cNvPicPr>
             <a:picLocks noChangeAspect="1"/>
           </p:cNvPicPr>
@@ -12229,8 +12329,8 @@
         </p:blipFill>
         <p:spPr>
           <a:xfrm>
-            <a:off x="629930" y="1783080"/>
-            <a:ext cx="10931835" cy="4270248"/>
+            <a:off x="0" y="658368"/>
+            <a:ext cx="5120640" cy="5833872"/>
           </a:xfrm>
           <a:prstGeom prst="rect">
             <a:avLst/>
@@ -12239,14 +12339,14 @@
       </p:pic>
       <p:sp>
         <p:nvSpPr>
-          <p:cNvPr id="5" name="Text 2"/>
+          <p:cNvPr id="4" name="Text 1"/>
           <p:cNvSpPr/>
           <p:nvPr/>
         </p:nvSpPr>
         <p:spPr>
           <a:xfrm>
-            <a:off x="457200" y="6089904"/>
-            <a:ext cx="11277295" cy="347472"/>
+            <a:off x="5349240" y="1005840"/>
+            <a:ext cx="6522415" cy="731520"/>
           </a:xfrm>
           <a:prstGeom prst="rect">
             <a:avLst/>
@@ -12255,24 +12355,85 @@
           <a:ln/>
         </p:spPr>
         <p:txBody>
-          <a:bodyPr wrap="square" lIns="0" tIns="0" rIns="0" bIns="0" rtlCol="0" anchor="ctr"/>
+          <a:bodyPr wrap="square" lIns="0" tIns="0" rIns="0" bIns="0" rtlCol="0" anchor="ctr">
+            <a:normAutofit/>
+          </a:bodyPr>
           <a:lstStyle/>
           <a:p>
             <a:pPr algn="ctr" indent="0" marL="0">
               <a:buNone/>
             </a:pPr>
             <a:r>
-              <a:rPr lang="en-US" sz="1800" i="1" dirty="0">
-                <a:solidFill>
-                  <a:srgbClr val="555555"/>
+              <a:rPr lang="en-US" sz="3600" b="1" dirty="0">
+                <a:solidFill>
+                  <a:srgbClr val="990011"/>
                 </a:solidFill>
                 <a:latin typeface="Times New Roman" pitchFamily="34" charset="0"/>
                 <a:ea typeface="Times New Roman" pitchFamily="34" charset="-122"/>
                 <a:cs typeface="Times New Roman" pitchFamily="34" charset="-120"/>
               </a:rPr>
-              <a:t>Illustration: the processes of denudation</a:t>
-            </a:r>
-            <a:endParaRPr lang="en-US" sz="1800" dirty="0"/>
+              <a:t>DEFINITIONS (continued)</a:t>
+            </a:r>
+            <a:endParaRPr lang="en-US" sz="3600" dirty="0"/>
+          </a:p>
+        </p:txBody>
+      </p:sp>
+      <p:sp>
+        <p:nvSpPr>
+          <p:cNvPr id="5" name="Text 2"/>
+          <p:cNvSpPr/>
+          <p:nvPr/>
+        </p:nvSpPr>
+        <p:spPr>
+          <a:xfrm>
+            <a:off x="5349240" y="1783080"/>
+            <a:ext cx="6522415" cy="4663440"/>
+          </a:xfrm>
+          <a:prstGeom prst="rect">
+            <a:avLst/>
+          </a:prstGeom>
+          <a:noFill/>
+          <a:ln/>
+        </p:spPr>
+        <p:txBody>
+          <a:bodyPr wrap="square" lIns="0" tIns="0" rIns="0" bIns="0" rtlCol="0" anchor="t"/>
+          <a:lstStyle/>
+          <a:p>
+            <a:pPr algn="l" indent="0" marL="0">
+              <a:spcAft>
+                <a:spcPts val="800"/>
+              </a:spcAft>
+              <a:buNone/>
+            </a:pPr>
+            <a:r>
+              <a:rPr lang="en-US" sz="4000" b="1" dirty="0">
+                <a:solidFill>
+                  <a:srgbClr val="111111"/>
+                </a:solidFill>
+                <a:latin typeface="Times New Roman" pitchFamily="34" charset="0"/>
+                <a:ea typeface="Times New Roman" pitchFamily="34" charset="-122"/>
+                <a:cs typeface="Times New Roman" pitchFamily="34" charset="-120"/>
+              </a:rPr>
+              <a:t>Agent of denudation: </a:t>
+            </a:r>
+            <a:pPr algn="l" indent="0" marL="0">
+              <a:spcAft>
+                <a:spcPts val="800"/>
+              </a:spcAft>
+              <a:buNone/>
+            </a:pPr>
+            <a:r>
+              <a:rPr lang="en-US" sz="4000" dirty="0">
+                <a:solidFill>
+                  <a:srgbClr val="111111"/>
+                </a:solidFill>
+                <a:latin typeface="Times New Roman" pitchFamily="34" charset="0"/>
+                <a:ea typeface="Times New Roman" pitchFamily="34" charset="-122"/>
+                <a:cs typeface="Times New Roman" pitchFamily="34" charset="-120"/>
+              </a:rPr>
+              <a:t>It is a natural force that wears down and carries away rock and soil.</a:t>
+            </a:r>
+            <a:endParaRPr lang="en-US" sz="4000" dirty="0"/>
           </a:p>
         </p:txBody>
       </p:sp>
@@ -12388,9 +12549,129 @@
           </a:p>
         </p:txBody>
       </p:sp>
+      <p:sp>
+        <p:nvSpPr>
+          <p:cNvPr id="3" name="Text 1"/>
+          <p:cNvSpPr/>
+          <p:nvPr/>
+        </p:nvSpPr>
+        <p:spPr>
+          <a:xfrm>
+            <a:off x="365760" y="1005840"/>
+            <a:ext cx="11460175" cy="731520"/>
+          </a:xfrm>
+          <a:prstGeom prst="rect">
+            <a:avLst/>
+          </a:prstGeom>
+          <a:noFill/>
+          <a:ln/>
+        </p:spPr>
+        <p:txBody>
+          <a:bodyPr wrap="square" lIns="0" tIns="0" rIns="0" bIns="0" rtlCol="0" anchor="ctr">
+            <a:normAutofit/>
+          </a:bodyPr>
+          <a:lstStyle/>
+          <a:p>
+            <a:pPr algn="ctr" indent="0" marL="0">
+              <a:buNone/>
+            </a:pPr>
+            <a:r>
+              <a:rPr lang="en-US" sz="3600" b="1" dirty="0">
+                <a:solidFill>
+                  <a:srgbClr val="990011"/>
+                </a:solidFill>
+                <a:latin typeface="Times New Roman" pitchFamily="34" charset="0"/>
+                <a:ea typeface="Times New Roman" pitchFamily="34" charset="-122"/>
+                <a:cs typeface="Times New Roman" pitchFamily="34" charset="-120"/>
+              </a:rPr>
+              <a:t>1. Major Processes of Denudation</a:t>
+            </a:r>
+            <a:endParaRPr lang="en-US" sz="3600" dirty="0"/>
+          </a:p>
+        </p:txBody>
+      </p:sp>
+      <p:sp>
+        <p:nvSpPr>
+          <p:cNvPr id="4" name="Text 2"/>
+          <p:cNvSpPr/>
+          <p:nvPr/>
+        </p:nvSpPr>
+        <p:spPr>
+          <a:xfrm>
+            <a:off x="365760" y="1783080"/>
+            <a:ext cx="4846320" cy="4617720"/>
+          </a:xfrm>
+          <a:prstGeom prst="rect">
+            <a:avLst/>
+          </a:prstGeom>
+          <a:noFill/>
+          <a:ln/>
+        </p:spPr>
+        <p:txBody>
+          <a:bodyPr wrap="square" lIns="0" tIns="0" rIns="0" bIns="0" rtlCol="0" anchor="t"/>
+          <a:lstStyle/>
+          <a:p>
+            <a:pPr algn="l" indent="0" marL="0">
+              <a:spcAft>
+                <a:spcPts val="800"/>
+              </a:spcAft>
+              <a:buNone/>
+            </a:pPr>
+            <a:r>
+              <a:rPr lang="en-US" sz="3600" i="1" dirty="0">
+                <a:solidFill>
+                  <a:srgbClr val="111111"/>
+                </a:solidFill>
+                <a:latin typeface="Times New Roman" pitchFamily="34" charset="0"/>
+                <a:ea typeface="Times New Roman" pitchFamily="34" charset="-122"/>
+                <a:cs typeface="Times New Roman" pitchFamily="34" charset="-120"/>
+              </a:rPr>
+              <a:t>Denudation takes place through the following processes:</a:t>
+            </a:r>
+            <a:endParaRPr lang="en-US" sz="3600" dirty="0"/>
+          </a:p>
+          <a:p>
+            <a:pPr algn="l" indent="0" marL="0">
+              <a:spcAft>
+                <a:spcPts val="800"/>
+              </a:spcAft>
+              <a:buNone/>
+            </a:pPr>
+            <a:r>
+              <a:rPr lang="en-US" sz="3600" b="1" dirty="0">
+                <a:solidFill>
+                  <a:srgbClr val="111111"/>
+                </a:solidFill>
+                <a:latin typeface="Times New Roman" pitchFamily="34" charset="0"/>
+                <a:ea typeface="Times New Roman" pitchFamily="34" charset="-122"/>
+                <a:cs typeface="Times New Roman" pitchFamily="34" charset="-120"/>
+              </a:rPr>
+              <a:t>Weathering: </a:t>
+            </a:r>
+            <a:pPr algn="l" indent="0" marL="0">
+              <a:spcAft>
+                <a:spcPts val="800"/>
+              </a:spcAft>
+              <a:buNone/>
+            </a:pPr>
+            <a:r>
+              <a:rPr lang="en-US" sz="3600" dirty="0">
+                <a:solidFill>
+                  <a:srgbClr val="111111"/>
+                </a:solidFill>
+                <a:latin typeface="Times New Roman" pitchFamily="34" charset="0"/>
+                <a:ea typeface="Times New Roman" pitchFamily="34" charset="-122"/>
+                <a:cs typeface="Times New Roman" pitchFamily="34" charset="-120"/>
+              </a:rPr>
+              <a:t>It is the breaking down of rocks in their place by the weather, plants and animals.</a:t>
+            </a:r>
+            <a:endParaRPr lang="en-US" sz="3600" dirty="0"/>
+          </a:p>
+        </p:txBody>
+      </p:sp>
       <p:pic>
         <p:nvPicPr>
-          <p:cNvPr id="3" name="Image 0" descr="/home/claude/f4/img/minesec_sheet.png">    </p:cNvPr>
+          <p:cNvPr id="5" name="Image 0" descr="/home/claude/f4/img/v2/denudation_last.png">    </p:cNvPr>
           <p:cNvPicPr>
             <a:picLocks noChangeAspect="1"/>
           </p:cNvPicPr>
@@ -12404,8 +12685,8 @@
         </p:blipFill>
         <p:spPr>
           <a:xfrm>
-            <a:off x="0" y="658368"/>
-            <a:ext cx="3840480" cy="5833872"/>
+            <a:off x="5349240" y="2617506"/>
+            <a:ext cx="6659575" cy="2601397"/>
           </a:xfrm>
           <a:prstGeom prst="rect">
             <a:avLst/>
@@ -12414,14 +12695,14 @@
       </p:pic>
       <p:sp>
         <p:nvSpPr>
-          <p:cNvPr id="4" name="Text 1"/>
+          <p:cNvPr id="6" name="Text 3"/>
           <p:cNvSpPr/>
           <p:nvPr/>
         </p:nvSpPr>
         <p:spPr>
           <a:xfrm>
-            <a:off x="4069080" y="1005840"/>
-            <a:ext cx="7802575" cy="731520"/>
+            <a:off x="5349240" y="6089904"/>
+            <a:ext cx="6659575" cy="347472"/>
           </a:xfrm>
           <a:prstGeom prst="rect">
             <a:avLst/>
@@ -12430,142 +12711,24 @@
           <a:ln/>
         </p:spPr>
         <p:txBody>
-          <a:bodyPr wrap="square" lIns="0" tIns="0" rIns="0" bIns="0" rtlCol="0" anchor="ctr">
-            <a:normAutofit/>
-          </a:bodyPr>
+          <a:bodyPr wrap="square" lIns="0" tIns="0" rIns="0" bIns="0" rtlCol="0" anchor="ctr"/>
           <a:lstStyle/>
           <a:p>
             <a:pPr algn="ctr" indent="0" marL="0">
               <a:buNone/>
             </a:pPr>
             <a:r>
-              <a:rPr lang="en-US" sz="3600" b="1" dirty="0">
-                <a:solidFill>
-                  <a:srgbClr val="990011"/>
+              <a:rPr lang="en-US" sz="1600" i="1" dirty="0">
+                <a:solidFill>
+                  <a:srgbClr val="555555"/>
                 </a:solidFill>
                 <a:latin typeface="Times New Roman" pitchFamily="34" charset="0"/>
                 <a:ea typeface="Times New Roman" pitchFamily="34" charset="-122"/>
                 <a:cs typeface="Times New Roman" pitchFamily="34" charset="-120"/>
               </a:rPr>
-              <a:t>3. Agents of Denudation</a:t>
-            </a:r>
-            <a:endParaRPr lang="en-US" sz="3600" dirty="0"/>
-          </a:p>
-        </p:txBody>
-      </p:sp>
-      <p:sp>
-        <p:nvSpPr>
-          <p:cNvPr id="5" name="Text 2"/>
-          <p:cNvSpPr/>
-          <p:nvPr/>
-        </p:nvSpPr>
-        <p:spPr>
-          <a:xfrm>
-            <a:off x="4069080" y="1783080"/>
-            <a:ext cx="7802575" cy="4663440"/>
-          </a:xfrm>
-          <a:prstGeom prst="rect">
-            <a:avLst/>
-          </a:prstGeom>
-          <a:noFill/>
-          <a:ln/>
-        </p:spPr>
-        <p:txBody>
-          <a:bodyPr wrap="square" lIns="0" tIns="0" rIns="0" bIns="0" rtlCol="0" anchor="t"/>
-          <a:lstStyle/>
-          <a:p>
-            <a:pPr algn="l" indent="0" marL="0">
-              <a:spcAft>
-                <a:spcPts val="800"/>
-              </a:spcAft>
-              <a:buNone/>
-            </a:pPr>
-            <a:r>
-              <a:rPr lang="en-US" sz="4000" i="1" dirty="0">
-                <a:solidFill>
-                  <a:srgbClr val="111111"/>
-                </a:solidFill>
-                <a:latin typeface="Times New Roman" pitchFamily="34" charset="0"/>
-                <a:ea typeface="Times New Roman" pitchFamily="34" charset="-122"/>
-                <a:cs typeface="Times New Roman" pitchFamily="34" charset="-120"/>
-              </a:rPr>
-              <a:t>The main agents of denudation are the following:</a:t>
-            </a:r>
-            <a:endParaRPr lang="en-US" sz="4000" dirty="0"/>
-          </a:p>
-          <a:p>
-            <a:pPr algn="l" indent="0" marL="0">
-              <a:spcAft>
-                <a:spcPts val="800"/>
-              </a:spcAft>
-              <a:buNone/>
-            </a:pPr>
-            <a:r>
-              <a:rPr lang="en-US" sz="4000" b="1" dirty="0">
-                <a:solidFill>
-                  <a:srgbClr val="111111"/>
-                </a:solidFill>
-                <a:latin typeface="Times New Roman" pitchFamily="34" charset="0"/>
-                <a:ea typeface="Times New Roman" pitchFamily="34" charset="-122"/>
-                <a:cs typeface="Times New Roman" pitchFamily="34" charset="-120"/>
-              </a:rPr>
-              <a:t>Running water: </a:t>
-            </a:r>
-            <a:pPr algn="l" indent="0" marL="0">
-              <a:spcAft>
-                <a:spcPts val="800"/>
-              </a:spcAft>
-              <a:buNone/>
-            </a:pPr>
-            <a:r>
-              <a:rPr lang="en-US" sz="4000" dirty="0">
-                <a:solidFill>
-                  <a:srgbClr val="111111"/>
-                </a:solidFill>
-                <a:latin typeface="Times New Roman" pitchFamily="34" charset="0"/>
-                <a:ea typeface="Times New Roman" pitchFamily="34" charset="-122"/>
-                <a:cs typeface="Times New Roman" pitchFamily="34" charset="-120"/>
-              </a:rPr>
-              <a:t>It is the most important agent, especially in wet regions.</a:t>
-            </a:r>
-            <a:endParaRPr lang="en-US" sz="4000" dirty="0"/>
-          </a:p>
-          <a:p>
-            <a:pPr algn="l" indent="0" marL="0">
-              <a:spcAft>
-                <a:spcPts val="800"/>
-              </a:spcAft>
-              <a:buNone/>
-            </a:pPr>
-            <a:r>
-              <a:rPr lang="en-US" sz="4000" b="1" dirty="0">
-                <a:solidFill>
-                  <a:srgbClr val="111111"/>
-                </a:solidFill>
-                <a:latin typeface="Times New Roman" pitchFamily="34" charset="0"/>
-                <a:ea typeface="Times New Roman" pitchFamily="34" charset="-122"/>
-                <a:cs typeface="Times New Roman" pitchFamily="34" charset="-120"/>
-              </a:rPr>
-              <a:t>Wind: </a:t>
-            </a:r>
-            <a:pPr algn="l" indent="0" marL="0">
-              <a:spcAft>
-                <a:spcPts val="800"/>
-              </a:spcAft>
-              <a:buNone/>
-            </a:pPr>
-            <a:r>
-              <a:rPr lang="en-US" sz="4000" dirty="0">
-                <a:solidFill>
-                  <a:srgbClr val="111111"/>
-                </a:solidFill>
-                <a:latin typeface="Times New Roman" pitchFamily="34" charset="0"/>
-                <a:ea typeface="Times New Roman" pitchFamily="34" charset="-122"/>
-                <a:cs typeface="Times New Roman" pitchFamily="34" charset="-120"/>
-              </a:rPr>
-              <a:t>It is a strong agent in deserts and semi-arid areas.</a:t>
-            </a:r>
-            <a:endParaRPr lang="en-US" sz="4000" dirty="0"/>
+              <a:t>Illustration: the processes of denudation</a:t>
+            </a:r>
+            <a:endParaRPr lang="en-US" sz="1600" dirty="0"/>
           </a:p>
         </p:txBody>
       </p:sp>
@@ -12681,9 +12844,109 @@
           </a:p>
         </p:txBody>
       </p:sp>
+      <p:sp>
+        <p:nvSpPr>
+          <p:cNvPr id="3" name="Text 1"/>
+          <p:cNvSpPr/>
+          <p:nvPr/>
+        </p:nvSpPr>
+        <p:spPr>
+          <a:xfrm>
+            <a:off x="365760" y="1005840"/>
+            <a:ext cx="11460175" cy="731520"/>
+          </a:xfrm>
+          <a:prstGeom prst="rect">
+            <a:avLst/>
+          </a:prstGeom>
+          <a:noFill/>
+          <a:ln/>
+        </p:spPr>
+        <p:txBody>
+          <a:bodyPr wrap="square" lIns="0" tIns="0" rIns="0" bIns="0" rtlCol="0" anchor="ctr">
+            <a:normAutofit/>
+          </a:bodyPr>
+          <a:lstStyle/>
+          <a:p>
+            <a:pPr algn="ctr" indent="0" marL="0">
+              <a:buNone/>
+            </a:pPr>
+            <a:r>
+              <a:rPr lang="en-US" sz="3600" b="1" dirty="0">
+                <a:solidFill>
+                  <a:srgbClr val="990011"/>
+                </a:solidFill>
+                <a:latin typeface="Times New Roman" pitchFamily="34" charset="0"/>
+                <a:ea typeface="Times New Roman" pitchFamily="34" charset="-122"/>
+                <a:cs typeface="Times New Roman" pitchFamily="34" charset="-120"/>
+              </a:rPr>
+              <a:t>1. Major Processes of Denudation</a:t>
+            </a:r>
+            <a:endParaRPr lang="en-US" sz="3600" dirty="0"/>
+          </a:p>
+        </p:txBody>
+      </p:sp>
+      <p:sp>
+        <p:nvSpPr>
+          <p:cNvPr id="4" name="Text 2"/>
+          <p:cNvSpPr/>
+          <p:nvPr/>
+        </p:nvSpPr>
+        <p:spPr>
+          <a:xfrm>
+            <a:off x="365760" y="1783080"/>
+            <a:ext cx="4846320" cy="4617720"/>
+          </a:xfrm>
+          <a:prstGeom prst="rect">
+            <a:avLst/>
+          </a:prstGeom>
+          <a:noFill/>
+          <a:ln/>
+        </p:spPr>
+        <p:txBody>
+          <a:bodyPr wrap="square" lIns="0" tIns="0" rIns="0" bIns="0" rtlCol="0" anchor="t"/>
+          <a:lstStyle/>
+          <a:p>
+            <a:pPr algn="l" indent="0" marL="0">
+              <a:spcAft>
+                <a:spcPts val="800"/>
+              </a:spcAft>
+              <a:buNone/>
+            </a:pPr>
+            <a:r>
+              <a:rPr lang="en-US" sz="3600" b="1" dirty="0">
+                <a:solidFill>
+                  <a:srgbClr val="111111"/>
+                </a:solidFill>
+                <a:latin typeface="Times New Roman" pitchFamily="34" charset="0"/>
+                <a:ea typeface="Times New Roman" pitchFamily="34" charset="-122"/>
+                <a:cs typeface="Times New Roman" pitchFamily="34" charset="-120"/>
+              </a:rPr>
+              <a:t>Erosion: </a:t>
+            </a:r>
+            <a:pPr algn="l" indent="0" marL="0">
+              <a:spcAft>
+                <a:spcPts val="800"/>
+              </a:spcAft>
+              <a:buNone/>
+            </a:pPr>
+            <a:r>
+              <a:rPr lang="en-US" sz="3600" dirty="0">
+                <a:solidFill>
+                  <a:srgbClr val="111111"/>
+                </a:solidFill>
+                <a:latin typeface="Times New Roman" pitchFamily="34" charset="0"/>
+                <a:ea typeface="Times New Roman" pitchFamily="34" charset="-122"/>
+                <a:cs typeface="Times New Roman" pitchFamily="34" charset="-120"/>
+              </a:rPr>
+              <a:t>It is the wearing away and removal of rock and soil by a moving agent.</a:t>
+            </a:r>
+            <a:endParaRPr lang="en-US" sz="3600" dirty="0"/>
+          </a:p>
+        </p:txBody>
+      </p:sp>
       <p:pic>
         <p:nvPicPr>
-          <p:cNvPr id="3" name="Image 0" descr="/home/claude/f4/img/minesec_sheet.png">    </p:cNvPr>
+          <p:cNvPr id="5" name="Image 0" descr="/home/claude/f4/img/v2/f4_gully.jpg">    </p:cNvPr>
           <p:cNvPicPr>
             <a:picLocks noChangeAspect="1"/>
           </p:cNvPicPr>
@@ -12697,8 +12960,8 @@
         </p:blipFill>
         <p:spPr>
           <a:xfrm>
-            <a:off x="0" y="658368"/>
-            <a:ext cx="5120640" cy="5833872"/>
+            <a:off x="5349240" y="2071212"/>
+            <a:ext cx="6659575" cy="3693983"/>
           </a:xfrm>
           <a:prstGeom prst="rect">
             <a:avLst/>
@@ -12707,14 +12970,14 @@
       </p:pic>
       <p:sp>
         <p:nvSpPr>
-          <p:cNvPr id="4" name="Text 1"/>
+          <p:cNvPr id="6" name="Text 3"/>
           <p:cNvSpPr/>
           <p:nvPr/>
         </p:nvSpPr>
         <p:spPr>
           <a:xfrm>
-            <a:off x="5349240" y="1005840"/>
-            <a:ext cx="6522415" cy="731520"/>
+            <a:off x="5349240" y="6089904"/>
+            <a:ext cx="6659575" cy="347472"/>
           </a:xfrm>
           <a:prstGeom prst="rect">
             <a:avLst/>
@@ -12723,122 +12986,24 @@
           <a:ln/>
         </p:spPr>
         <p:txBody>
-          <a:bodyPr wrap="square" lIns="0" tIns="0" rIns="0" bIns="0" rtlCol="0" anchor="ctr">
-            <a:normAutofit/>
-          </a:bodyPr>
+          <a:bodyPr wrap="square" lIns="0" tIns="0" rIns="0" bIns="0" rtlCol="0" anchor="ctr"/>
           <a:lstStyle/>
           <a:p>
             <a:pPr algn="ctr" indent="0" marL="0">
               <a:buNone/>
             </a:pPr>
             <a:r>
-              <a:rPr lang="en-US" sz="3600" b="1" dirty="0">
-                <a:solidFill>
-                  <a:srgbClr val="990011"/>
+              <a:rPr lang="en-US" sz="1600" i="1" dirty="0">
+                <a:solidFill>
+                  <a:srgbClr val="555555"/>
                 </a:solidFill>
                 <a:latin typeface="Times New Roman" pitchFamily="34" charset="0"/>
                 <a:ea typeface="Times New Roman" pitchFamily="34" charset="-122"/>
                 <a:cs typeface="Times New Roman" pitchFamily="34" charset="-120"/>
               </a:rPr>
-              <a:t>3. Agents of Denudation (continued)</a:t>
-            </a:r>
-            <a:endParaRPr lang="en-US" sz="3600" dirty="0"/>
-          </a:p>
-        </p:txBody>
-      </p:sp>
-      <p:sp>
-        <p:nvSpPr>
-          <p:cNvPr id="5" name="Text 2"/>
-          <p:cNvSpPr/>
-          <p:nvPr/>
-        </p:nvSpPr>
-        <p:spPr>
-          <a:xfrm>
-            <a:off x="5349240" y="1783080"/>
-            <a:ext cx="6522415" cy="4663440"/>
-          </a:xfrm>
-          <a:prstGeom prst="rect">
-            <a:avLst/>
-          </a:prstGeom>
-          <a:noFill/>
-          <a:ln/>
-        </p:spPr>
-        <p:txBody>
-          <a:bodyPr wrap="square" lIns="0" tIns="0" rIns="0" bIns="0" rtlCol="0" anchor="t"/>
-          <a:lstStyle/>
-          <a:p>
-            <a:pPr algn="l" indent="0" marL="0">
-              <a:spcAft>
-                <a:spcPts val="800"/>
-              </a:spcAft>
-              <a:buNone/>
-            </a:pPr>
-            <a:r>
-              <a:rPr lang="en-US" sz="4000" b="1" dirty="0">
-                <a:solidFill>
-                  <a:srgbClr val="111111"/>
-                </a:solidFill>
-                <a:latin typeface="Times New Roman" pitchFamily="34" charset="0"/>
-                <a:ea typeface="Times New Roman" pitchFamily="34" charset="-122"/>
-                <a:cs typeface="Times New Roman" pitchFamily="34" charset="-120"/>
-              </a:rPr>
-              <a:t>Waves: </a:t>
-            </a:r>
-            <a:pPr algn="l" indent="0" marL="0">
-              <a:spcAft>
-                <a:spcPts val="800"/>
-              </a:spcAft>
-              <a:buNone/>
-            </a:pPr>
-            <a:r>
-              <a:rPr lang="en-US" sz="4000" dirty="0">
-                <a:solidFill>
-                  <a:srgbClr val="111111"/>
-                </a:solidFill>
-                <a:latin typeface="Times New Roman" pitchFamily="34" charset="0"/>
-                <a:ea typeface="Times New Roman" pitchFamily="34" charset="-122"/>
-                <a:cs typeface="Times New Roman" pitchFamily="34" charset="-120"/>
-              </a:rPr>
-              <a:t>They wear away and build up the coast, as at Kribi and Limbe.</a:t>
-            </a:r>
-            <a:endParaRPr lang="en-US" sz="4000" dirty="0"/>
-          </a:p>
-          <a:p>
-            <a:pPr algn="l" indent="0" marL="0">
-              <a:spcAft>
-                <a:spcPts val="800"/>
-              </a:spcAft>
-              <a:buNone/>
-            </a:pPr>
-            <a:r>
-              <a:rPr lang="en-US" sz="4000" b="1" dirty="0">
-                <a:solidFill>
-                  <a:srgbClr val="111111"/>
-                </a:solidFill>
-                <a:latin typeface="Times New Roman" pitchFamily="34" charset="0"/>
-                <a:ea typeface="Times New Roman" pitchFamily="34" charset="-122"/>
-                <a:cs typeface="Times New Roman" pitchFamily="34" charset="-120"/>
-              </a:rPr>
-              <a:t>Ice: </a:t>
-            </a:r>
-            <a:pPr algn="l" indent="0" marL="0">
-              <a:spcAft>
-                <a:spcPts val="800"/>
-              </a:spcAft>
-              <a:buNone/>
-            </a:pPr>
-            <a:r>
-              <a:rPr lang="en-US" sz="4000" dirty="0">
-                <a:solidFill>
-                  <a:srgbClr val="111111"/>
-                </a:solidFill>
-                <a:latin typeface="Times New Roman" pitchFamily="34" charset="0"/>
-                <a:ea typeface="Times New Roman" pitchFamily="34" charset="-122"/>
-                <a:cs typeface="Times New Roman" pitchFamily="34" charset="-120"/>
-              </a:rPr>
-              <a:t>It acts in cold mountains and polar regions.</a:t>
-            </a:r>
-            <a:endParaRPr lang="en-US" sz="4000" dirty="0"/>
+              <a:t>Illustration: erosion by rain water</a:t>
+            </a:r>
+            <a:endParaRPr lang="en-US" sz="1600" dirty="0"/>
           </a:p>
         </p:txBody>
       </p:sp>
@@ -12948,7 +13113,7 @@
                 <a:ea typeface="Calibri" pitchFamily="34" charset="-122"/>
                 <a:cs typeface="Calibri" pitchFamily="34" charset="-120"/>
               </a:rPr>
-              <a:t>FORMATIVE EVALUATION</a:t>
+              <a:t>BOARD SUMMARY</a:t>
             </a:r>
             <a:endParaRPr lang="en-US" sz="1400" dirty="0"/>
           </a:p>
@@ -13013,7 +13178,7 @@
                 <a:ea typeface="Times New Roman" pitchFamily="34" charset="-122"/>
                 <a:cs typeface="Times New Roman" pitchFamily="34" charset="-120"/>
               </a:rPr>
-              <a:t>Evaluation 1</a:t>
+              <a:t>1. Major Processes of Denudation</a:t>
             </a:r>
             <a:endParaRPr lang="en-US" sz="3600" dirty="0"/>
           </a:p>
@@ -13047,7 +13212,7 @@
               <a:buNone/>
             </a:pPr>
             <a:r>
-              <a:rPr lang="en-US" sz="4000" dirty="0">
+              <a:rPr lang="en-US" sz="4000" b="1" dirty="0">
                 <a:solidFill>
                   <a:srgbClr val="111111"/>
                 </a:solidFill>
@@ -13055,7 +13220,24 @@
                 <a:ea typeface="Times New Roman" pitchFamily="34" charset="-122"/>
                 <a:cs typeface="Times New Roman" pitchFamily="34" charset="-120"/>
               </a:rPr>
-              <a:t>What is denudation?</a:t>
+              <a:t>Transportation: </a:t>
+            </a:r>
+            <a:pPr algn="l" indent="0" marL="0">
+              <a:spcAft>
+                <a:spcPts val="800"/>
+              </a:spcAft>
+              <a:buNone/>
+            </a:pPr>
+            <a:r>
+              <a:rPr lang="en-US" sz="4000" dirty="0">
+                <a:solidFill>
+                  <a:srgbClr val="111111"/>
+                </a:solidFill>
+                <a:latin typeface="Times New Roman" pitchFamily="34" charset="0"/>
+                <a:ea typeface="Times New Roman" pitchFamily="34" charset="-122"/>
+                <a:cs typeface="Times New Roman" pitchFamily="34" charset="-120"/>
+              </a:rPr>
+              <a:t>It is the carrying away of the eroded material by the agent, until the agent loses energy and drops it.</a:t>
             </a:r>
             <a:endParaRPr lang="en-US" sz="4000" dirty="0"/>
           </a:p>
@@ -13167,15 +13349,135 @@
                 <a:ea typeface="Calibri" pitchFamily="34" charset="-122"/>
                 <a:cs typeface="Calibri" pitchFamily="34" charset="-120"/>
               </a:rPr>
-              <a:t>FORMATIVE EVALUATION</a:t>
+              <a:t>BOARD SUMMARY</a:t>
             </a:r>
             <a:endParaRPr lang="en-US" sz="1400" dirty="0"/>
+          </a:p>
+        </p:txBody>
+      </p:sp>
+      <p:sp>
+        <p:nvSpPr>
+          <p:cNvPr id="3" name="Text 1"/>
+          <p:cNvSpPr/>
+          <p:nvPr/>
+        </p:nvSpPr>
+        <p:spPr>
+          <a:xfrm>
+            <a:off x="365760" y="1005840"/>
+            <a:ext cx="11460175" cy="731520"/>
+          </a:xfrm>
+          <a:prstGeom prst="rect">
+            <a:avLst/>
+          </a:prstGeom>
+          <a:noFill/>
+          <a:ln/>
+        </p:spPr>
+        <p:txBody>
+          <a:bodyPr wrap="square" lIns="0" tIns="0" rIns="0" bIns="0" rtlCol="0" anchor="ctr">
+            <a:normAutofit/>
+          </a:bodyPr>
+          <a:lstStyle/>
+          <a:p>
+            <a:pPr algn="ctr" indent="0" marL="0">
+              <a:buNone/>
+            </a:pPr>
+            <a:r>
+              <a:rPr lang="en-US" sz="3600" b="1" dirty="0">
+                <a:solidFill>
+                  <a:srgbClr val="990011"/>
+                </a:solidFill>
+                <a:latin typeface="Times New Roman" pitchFamily="34" charset="0"/>
+                <a:ea typeface="Times New Roman" pitchFamily="34" charset="-122"/>
+                <a:cs typeface="Times New Roman" pitchFamily="34" charset="-120"/>
+              </a:rPr>
+              <a:t>2. Main Agents of Denudation</a:t>
+            </a:r>
+            <a:endParaRPr lang="en-US" sz="3600" dirty="0"/>
+          </a:p>
+        </p:txBody>
+      </p:sp>
+      <p:sp>
+        <p:nvSpPr>
+          <p:cNvPr id="4" name="Text 2"/>
+          <p:cNvSpPr/>
+          <p:nvPr/>
+        </p:nvSpPr>
+        <p:spPr>
+          <a:xfrm>
+            <a:off x="365760" y="1783080"/>
+            <a:ext cx="4846320" cy="4617720"/>
+          </a:xfrm>
+          <a:prstGeom prst="rect">
+            <a:avLst/>
+          </a:prstGeom>
+          <a:noFill/>
+          <a:ln/>
+        </p:spPr>
+        <p:txBody>
+          <a:bodyPr wrap="square" lIns="0" tIns="0" rIns="0" bIns="0" rtlCol="0" anchor="t"/>
+          <a:lstStyle/>
+          <a:p>
+            <a:pPr algn="l" indent="0" marL="0">
+              <a:spcAft>
+                <a:spcPts val="800"/>
+              </a:spcAft>
+              <a:buNone/>
+            </a:pPr>
+            <a:r>
+              <a:rPr lang="en-US" sz="3200" i="1" dirty="0">
+                <a:solidFill>
+                  <a:srgbClr val="111111"/>
+                </a:solidFill>
+                <a:latin typeface="Times New Roman" pitchFamily="34" charset="0"/>
+                <a:ea typeface="Times New Roman" pitchFamily="34" charset="-122"/>
+                <a:cs typeface="Times New Roman" pitchFamily="34" charset="-120"/>
+              </a:rPr>
+              <a:t>The main agents of denudation are the following:</a:t>
+            </a:r>
+            <a:endParaRPr lang="en-US" sz="3200" dirty="0"/>
+          </a:p>
+          <a:p>
+            <a:pPr algn="l" indent="0" marL="0">
+              <a:spcAft>
+                <a:spcPts val="800"/>
+              </a:spcAft>
+              <a:buNone/>
+            </a:pPr>
+            <a:r>
+              <a:rPr lang="en-US" sz="3200" b="1" dirty="0">
+                <a:solidFill>
+                  <a:srgbClr val="111111"/>
+                </a:solidFill>
+                <a:latin typeface="Times New Roman" pitchFamily="34" charset="0"/>
+                <a:ea typeface="Times New Roman" pitchFamily="34" charset="-122"/>
+                <a:cs typeface="Times New Roman" pitchFamily="34" charset="-120"/>
+              </a:rPr>
+              <a:t>Running water: </a:t>
+            </a:r>
+            <a:pPr algn="l" indent="0" marL="0">
+              <a:spcAft>
+                <a:spcPts val="800"/>
+              </a:spcAft>
+              <a:buNone/>
+            </a:pPr>
+            <a:r>
+              <a:rPr lang="en-US" sz="3200" dirty="0">
+                <a:solidFill>
+                  <a:srgbClr val="111111"/>
+                </a:solidFill>
+                <a:latin typeface="Times New Roman" pitchFamily="34" charset="0"/>
+                <a:ea typeface="Times New Roman" pitchFamily="34" charset="-122"/>
+                <a:cs typeface="Times New Roman" pitchFamily="34" charset="-120"/>
+              </a:rPr>
+              <a:t>Rain and rivers wear away and carry soil and rock, and they are the most important agent in wet regions.</a:t>
+            </a:r>
+            <a:endParaRPr lang="en-US" sz="3200" dirty="0"/>
           </a:p>
         </p:txBody>
       </p:sp>
       <p:pic>
         <p:nvPicPr>
-          <p:cNvPr id="3" name="Image 0" descr="/home/claude/f4/img/minesec_sheet.png">    </p:cNvPr>
+          <p:cNvPr id="5" name="Image 0" descr="/home/claude/f4/img/v2/f4_muddyriver.jpg">    </p:cNvPr>
           <p:cNvPicPr>
             <a:picLocks noChangeAspect="1"/>
           </p:cNvPicPr>
@@ -13189,8 +13491,8 @@
         </p:blipFill>
         <p:spPr>
           <a:xfrm>
-            <a:off x="0" y="658368"/>
-            <a:ext cx="5120640" cy="5833872"/>
+            <a:off x="5349240" y="2069407"/>
+            <a:ext cx="6659575" cy="3697594"/>
           </a:xfrm>
           <a:prstGeom prst="rect">
             <a:avLst/>
@@ -13199,14 +13501,14 @@
       </p:pic>
       <p:sp>
         <p:nvSpPr>
-          <p:cNvPr id="4" name="Text 1"/>
+          <p:cNvPr id="6" name="Text 3"/>
           <p:cNvSpPr/>
           <p:nvPr/>
         </p:nvSpPr>
         <p:spPr>
           <a:xfrm>
-            <a:off x="5349240" y="1005840"/>
-            <a:ext cx="6522415" cy="731520"/>
+            <a:off x="5349240" y="6089904"/>
+            <a:ext cx="6659575" cy="347472"/>
           </a:xfrm>
           <a:prstGeom prst="rect">
             <a:avLst/>
@@ -13215,68 +13517,24 @@
           <a:ln/>
         </p:spPr>
         <p:txBody>
-          <a:bodyPr wrap="square" lIns="0" tIns="0" rIns="0" bIns="0" rtlCol="0" anchor="ctr">
-            <a:normAutofit/>
-          </a:bodyPr>
+          <a:bodyPr wrap="square" lIns="0" tIns="0" rIns="0" bIns="0" rtlCol="0" anchor="ctr"/>
           <a:lstStyle/>
           <a:p>
             <a:pPr algn="ctr" indent="0" marL="0">
               <a:buNone/>
             </a:pPr>
             <a:r>
-              <a:rPr lang="en-US" sz="3600" b="1" dirty="0">
-                <a:solidFill>
-                  <a:srgbClr val="990011"/>
+              <a:rPr lang="en-US" sz="1600" i="1" dirty="0">
+                <a:solidFill>
+                  <a:srgbClr val="555555"/>
                 </a:solidFill>
                 <a:latin typeface="Times New Roman" pitchFamily="34" charset="0"/>
                 <a:ea typeface="Times New Roman" pitchFamily="34" charset="-122"/>
                 <a:cs typeface="Times New Roman" pitchFamily="34" charset="-120"/>
               </a:rPr>
-              <a:t>Expected Answer</a:t>
-            </a:r>
-            <a:endParaRPr lang="en-US" sz="3600" dirty="0"/>
-          </a:p>
-        </p:txBody>
-      </p:sp>
-      <p:sp>
-        <p:nvSpPr>
-          <p:cNvPr id="5" name="Text 2"/>
-          <p:cNvSpPr/>
-          <p:nvPr/>
-        </p:nvSpPr>
-        <p:spPr>
-          <a:xfrm>
-            <a:off x="5349240" y="1783080"/>
-            <a:ext cx="6522415" cy="4663440"/>
-          </a:xfrm>
-          <a:prstGeom prst="rect">
-            <a:avLst/>
-          </a:prstGeom>
-          <a:noFill/>
-          <a:ln/>
-        </p:spPr>
-        <p:txBody>
-          <a:bodyPr wrap="square" lIns="0" tIns="0" rIns="0" bIns="0" rtlCol="0" anchor="t"/>
-          <a:lstStyle/>
-          <a:p>
-            <a:pPr algn="l" indent="0" marL="0">
-              <a:spcAft>
-                <a:spcPts val="800"/>
-              </a:spcAft>
-              <a:buNone/>
-            </a:pPr>
-            <a:r>
-              <a:rPr lang="en-US" sz="4000" dirty="0">
-                <a:solidFill>
-                  <a:srgbClr val="111111"/>
-                </a:solidFill>
-                <a:latin typeface="Times New Roman" pitchFamily="34" charset="0"/>
-                <a:ea typeface="Times New Roman" pitchFamily="34" charset="-122"/>
-                <a:cs typeface="Times New Roman" pitchFamily="34" charset="-120"/>
-              </a:rPr>
-              <a:t>The wearing down of the land.</a:t>
-            </a:r>
-            <a:endParaRPr lang="en-US" sz="4000" dirty="0"/>
+              <a:t>Illustration: a muddy river</a:t>
+            </a:r>
+            <a:endParaRPr lang="en-US" sz="1600" dirty="0"/>
           </a:p>
         </p:txBody>
       </p:sp>
@@ -13386,7 +13644,7 @@
                 <a:ea typeface="Calibri" pitchFamily="34" charset="-122"/>
                 <a:cs typeface="Calibri" pitchFamily="34" charset="-120"/>
               </a:rPr>
-              <a:t>FORMATIVE EVALUATION</a:t>
+              <a:t>BOARD SUMMARY</a:t>
             </a:r>
             <a:endParaRPr lang="en-US" sz="1400" dirty="0"/>
           </a:p>
@@ -13409,7 +13667,7 @@
         <p:spPr>
           <a:xfrm>
             <a:off x="0" y="658368"/>
-            <a:ext cx="5120640" cy="5833872"/>
+            <a:ext cx="2468880" cy="5833872"/>
           </a:xfrm>
           <a:prstGeom prst="rect">
             <a:avLst/>
@@ -13424,8 +13682,8 @@
         </p:nvSpPr>
         <p:spPr>
           <a:xfrm>
-            <a:off x="5349240" y="1005840"/>
-            <a:ext cx="6522415" cy="731520"/>
+            <a:off x="2697480" y="1005840"/>
+            <a:ext cx="9174175" cy="731520"/>
           </a:xfrm>
           <a:prstGeom prst="rect">
             <a:avLst/>
@@ -13451,7 +13709,7 @@
                 <a:ea typeface="Times New Roman" pitchFamily="34" charset="-122"/>
                 <a:cs typeface="Times New Roman" pitchFamily="34" charset="-120"/>
               </a:rPr>
-              <a:t>Evaluation 2</a:t>
+              <a:t>2. Main Agents of Denudation</a:t>
             </a:r>
             <a:endParaRPr lang="en-US" sz="3600" dirty="0"/>
           </a:p>
@@ -13465,8 +13723,8 @@
         </p:nvSpPr>
         <p:spPr>
           <a:xfrm>
-            <a:off x="5349240" y="1783080"/>
-            <a:ext cx="6522415" cy="4663440"/>
+            <a:off x="2697480" y="1783080"/>
+            <a:ext cx="9174175" cy="4663440"/>
           </a:xfrm>
           <a:prstGeom prst="rect">
             <a:avLst/>
@@ -13485,7 +13743,7 @@
               <a:buNone/>
             </a:pPr>
             <a:r>
-              <a:rPr lang="en-US" sz="4000" dirty="0">
+              <a:rPr lang="en-US" sz="4000" b="1" dirty="0">
                 <a:solidFill>
                   <a:srgbClr val="111111"/>
                 </a:solidFill>
@@ -13493,7 +13751,61 @@
                 <a:ea typeface="Times New Roman" pitchFamily="34" charset="-122"/>
                 <a:cs typeface="Times New Roman" pitchFamily="34" charset="-120"/>
               </a:rPr>
-              <a:t>Name the four processes of denudation.</a:t>
+              <a:t>Wind: </a:t>
+            </a:r>
+            <a:pPr algn="l" indent="0" marL="0">
+              <a:spcAft>
+                <a:spcPts val="800"/>
+              </a:spcAft>
+              <a:buNone/>
+            </a:pPr>
+            <a:r>
+              <a:rPr lang="en-US" sz="4000" dirty="0">
+                <a:solidFill>
+                  <a:srgbClr val="111111"/>
+                </a:solidFill>
+                <a:latin typeface="Times New Roman" pitchFamily="34" charset="0"/>
+                <a:ea typeface="Times New Roman" pitchFamily="34" charset="-122"/>
+                <a:cs typeface="Times New Roman" pitchFamily="34" charset="-120"/>
+              </a:rPr>
+              <a:t>Wind blows away loose sand and dust and wears rocks, especially in deserts and semi-arid areas such as the Far North.</a:t>
+            </a:r>
+            <a:endParaRPr lang="en-US" sz="4000" dirty="0"/>
+          </a:p>
+          <a:p>
+            <a:pPr algn="l" indent="0" marL="0">
+              <a:spcAft>
+                <a:spcPts val="800"/>
+              </a:spcAft>
+              <a:buNone/>
+            </a:pPr>
+            <a:r>
+              <a:rPr lang="en-US" sz="4000" b="1" dirty="0">
+                <a:solidFill>
+                  <a:srgbClr val="111111"/>
+                </a:solidFill>
+                <a:latin typeface="Times New Roman" pitchFamily="34" charset="0"/>
+                <a:ea typeface="Times New Roman" pitchFamily="34" charset="-122"/>
+                <a:cs typeface="Times New Roman" pitchFamily="34" charset="-120"/>
+              </a:rPr>
+              <a:t>Waves: </a:t>
+            </a:r>
+            <a:pPr algn="l" indent="0" marL="0">
+              <a:spcAft>
+                <a:spcPts val="800"/>
+              </a:spcAft>
+              <a:buNone/>
+            </a:pPr>
+            <a:r>
+              <a:rPr lang="en-US" sz="4000" dirty="0">
+                <a:solidFill>
+                  <a:srgbClr val="111111"/>
+                </a:solidFill>
+                <a:latin typeface="Times New Roman" pitchFamily="34" charset="0"/>
+                <a:ea typeface="Times New Roman" pitchFamily="34" charset="-122"/>
+                <a:cs typeface="Times New Roman" pitchFamily="34" charset="-120"/>
+              </a:rPr>
+              <a:t>Sea waves wear away and build up the coast, as at Kribi and Limbe.</a:t>
             </a:r>
             <a:endParaRPr lang="en-US" sz="4000" dirty="0"/>
           </a:p>
@@ -13670,7 +13982,7 @@
                 <a:ea typeface="Times New Roman" pitchFamily="34" charset="-122"/>
                 <a:cs typeface="Times New Roman" pitchFamily="34" charset="-120"/>
               </a:rPr>
-              <a:t>Expected Answer</a:t>
+              <a:t>Evaluation 1</a:t>
             </a:r>
             <a:endParaRPr lang="en-US" sz="3600" dirty="0"/>
           </a:p>
@@ -13712,7 +14024,7 @@
                 <a:ea typeface="Times New Roman" pitchFamily="34" charset="-122"/>
                 <a:cs typeface="Times New Roman" pitchFamily="34" charset="-120"/>
               </a:rPr>
-              <a:t>Weathering, erosion, transport and deposition.</a:t>
+              <a:t>What is denudation?</a:t>
             </a:r>
             <a:endParaRPr lang="en-US" sz="4000" dirty="0"/>
           </a:p>
@@ -13824,7 +14136,7 @@
                 <a:ea typeface="Calibri" pitchFamily="34" charset="-122"/>
                 <a:cs typeface="Calibri" pitchFamily="34" charset="-120"/>
               </a:rPr>
-              <a:t>REMEDIATION</a:t>
+              <a:t>FORMATIVE EVALUATION</a:t>
             </a:r>
             <a:endParaRPr lang="en-US" sz="1400" dirty="0"/>
           </a:p>
@@ -13847,7 +14159,7 @@
         <p:spPr>
           <a:xfrm>
             <a:off x="0" y="658368"/>
-            <a:ext cx="2468880" cy="5833872"/>
+            <a:ext cx="5120640" cy="5833872"/>
           </a:xfrm>
           <a:prstGeom prst="rect">
             <a:avLst/>
@@ -13862,8 +14174,8 @@
         </p:nvSpPr>
         <p:spPr>
           <a:xfrm>
-            <a:off x="2697480" y="1005840"/>
-            <a:ext cx="9174175" cy="731520"/>
+            <a:off x="5349240" y="1005840"/>
+            <a:ext cx="6522415" cy="731520"/>
           </a:xfrm>
           <a:prstGeom prst="rect">
             <a:avLst/>
@@ -13889,7 +14201,7 @@
                 <a:ea typeface="Times New Roman" pitchFamily="34" charset="-122"/>
                 <a:cs typeface="Times New Roman" pitchFamily="34" charset="-120"/>
               </a:rPr>
-              <a:t>Remediation</a:t>
+              <a:t>Expected Answer</a:t>
             </a:r>
             <a:endParaRPr lang="en-US" sz="3600" dirty="0"/>
           </a:p>
@@ -13903,8 +14215,8 @@
         </p:nvSpPr>
         <p:spPr>
           <a:xfrm>
-            <a:off x="2697480" y="1783080"/>
-            <a:ext cx="9174175" cy="4663440"/>
+            <a:off x="5349240" y="1783080"/>
+            <a:ext cx="6522415" cy="4663440"/>
           </a:xfrm>
           <a:prstGeom prst="rect">
             <a:avLst/>
@@ -13923,7 +14235,7 @@
               <a:buNone/>
             </a:pPr>
             <a:r>
-              <a:rPr lang="en-US" sz="4000" b="1" dirty="0">
+              <a:rPr lang="en-US" sz="4000" dirty="0">
                 <a:solidFill>
                   <a:srgbClr val="111111"/>
                 </a:solidFill>
@@ -13931,73 +14243,7 @@
                 <a:ea typeface="Times New Roman" pitchFamily="34" charset="-122"/>
                 <a:cs typeface="Times New Roman" pitchFamily="34" charset="-120"/>
               </a:rPr>
-              <a:t>Fill in the blanks:</a:t>
-            </a:r>
-            <a:endParaRPr lang="en-US" sz="4000" dirty="0"/>
-          </a:p>
-          <a:p>
-            <a:pPr algn="l" marL="342900" indent="-342900">
-              <a:spcAft>
-                <a:spcPts val="800"/>
-              </a:spcAft>
-              <a:buSzPct val="100000"/>
-              <a:buFont typeface="+mj-lt"/>
-              <a:buAutoNum type="arabicPeriod" startAt="1"/>
-            </a:pPr>
-            <a:r>
-              <a:rPr lang="en-US" sz="4000" dirty="0">
-                <a:solidFill>
-                  <a:srgbClr val="111111"/>
-                </a:solidFill>
-                <a:latin typeface="Times New Roman" pitchFamily="34" charset="0"/>
-                <a:ea typeface="Times New Roman" pitchFamily="34" charset="-122"/>
-                <a:cs typeface="Times New Roman" pitchFamily="34" charset="-120"/>
-              </a:rPr>
-              <a:t>The breaking of rocks in their place is ______.</a:t>
-            </a:r>
-            <a:endParaRPr lang="en-US" sz="4000" dirty="0"/>
-          </a:p>
-          <a:p>
-            <a:pPr algn="l" marL="342900" indent="-342900">
-              <a:spcAft>
-                <a:spcPts val="800"/>
-              </a:spcAft>
-              <a:buSzPct val="100000"/>
-              <a:buFont typeface="+mj-lt"/>
-              <a:buAutoNum type="arabicPeriod" startAt="1"/>
-            </a:pPr>
-            <a:r>
-              <a:rPr lang="en-US" sz="4000" dirty="0">
-                <a:solidFill>
-                  <a:srgbClr val="111111"/>
-                </a:solidFill>
-                <a:latin typeface="Times New Roman" pitchFamily="34" charset="0"/>
-                <a:ea typeface="Times New Roman" pitchFamily="34" charset="-122"/>
-                <a:cs typeface="Times New Roman" pitchFamily="34" charset="-120"/>
-              </a:rPr>
-              <a:t>The dropping of material is ______.</a:t>
-            </a:r>
-            <a:endParaRPr lang="en-US" sz="4000" dirty="0"/>
-          </a:p>
-          <a:p>
-            <a:pPr algn="l" marL="342900" indent="-342900">
-              <a:spcAft>
-                <a:spcPts val="800"/>
-              </a:spcAft>
-              <a:buSzPct val="100000"/>
-              <a:buFont typeface="+mj-lt"/>
-              <a:buAutoNum type="arabicPeriod" startAt="1"/>
-            </a:pPr>
-            <a:r>
-              <a:rPr lang="en-US" sz="4000" dirty="0">
-                <a:solidFill>
-                  <a:srgbClr val="111111"/>
-                </a:solidFill>
-                <a:latin typeface="Times New Roman" pitchFamily="34" charset="0"/>
-                <a:ea typeface="Times New Roman" pitchFamily="34" charset="-122"/>
-                <a:cs typeface="Times New Roman" pitchFamily="34" charset="-120"/>
-              </a:rPr>
-              <a:t>The most important agent of denudation is running ______.</a:t>
+              <a:t>The wearing down of the land.</a:t>
             </a:r>
             <a:endParaRPr lang="en-US" sz="4000" dirty="0"/>
           </a:p>
@@ -14109,7 +14355,7 @@
                 <a:ea typeface="Calibri" pitchFamily="34" charset="-122"/>
                 <a:cs typeface="Calibri" pitchFamily="34" charset="-120"/>
               </a:rPr>
-              <a:t>HOMEWORK</a:t>
+              <a:t>FORMATIVE EVALUATION</a:t>
             </a:r>
             <a:endParaRPr lang="en-US" sz="1400" dirty="0"/>
           </a:p>
@@ -14174,7 +14420,7 @@
                 <a:ea typeface="Times New Roman" pitchFamily="34" charset="-122"/>
                 <a:cs typeface="Times New Roman" pitchFamily="34" charset="-120"/>
               </a:rPr>
-              <a:t>Homework</a:t>
+              <a:t>Evaluation 2</a:t>
             </a:r>
             <a:endParaRPr lang="en-US" sz="3600" dirty="0"/>
           </a:p>
@@ -14216,7 +14462,7 @@
                 <a:ea typeface="Times New Roman" pitchFamily="34" charset="-122"/>
                 <a:cs typeface="Times New Roman" pitchFamily="34" charset="-120"/>
               </a:rPr>
-              <a:t>Compare an old wall and a new wall in your area. Write three differences you see, and suggest what damaged the old wall.</a:t>
+              <a:t>Name the four processes of denudation.</a:t>
             </a:r>
             <a:endParaRPr lang="en-US" sz="4000" dirty="0"/>
           </a:p>
@@ -14567,7 +14813,7 @@
                 <a:ea typeface="Calibri" pitchFamily="34" charset="-122"/>
                 <a:cs typeface="Calibri" pitchFamily="34" charset="-120"/>
               </a:rPr>
-              <a:t>NEXT LESSON</a:t>
+              <a:t>FORMATIVE EVALUATION</a:t>
             </a:r>
             <a:endParaRPr lang="en-US" sz="1400" dirty="0"/>
           </a:p>
@@ -14632,7 +14878,7 @@
                 <a:ea typeface="Times New Roman" pitchFamily="34" charset="-122"/>
                 <a:cs typeface="Times New Roman" pitchFamily="34" charset="-120"/>
               </a:rPr>
-              <a:t>Next Lesson</a:t>
+              <a:t>Expected Answer</a:t>
             </a:r>
             <a:endParaRPr lang="en-US" sz="3600" dirty="0"/>
           </a:p>
@@ -14656,17 +14902,17 @@
           <a:ln/>
         </p:spPr>
         <p:txBody>
-          <a:bodyPr wrap="square" lIns="0" tIns="0" rIns="0" bIns="0" rtlCol="0" anchor="ctr"/>
-          <a:lstStyle/>
-          <a:p>
-            <a:pPr algn="ctr" indent="0" marL="0">
+          <a:bodyPr wrap="square" lIns="0" tIns="0" rIns="0" bIns="0" rtlCol="0" anchor="t"/>
+          <a:lstStyle/>
+          <a:p>
+            <a:pPr algn="l" indent="0" marL="0">
               <a:spcAft>
                 <a:spcPts val="800"/>
               </a:spcAft>
               <a:buNone/>
             </a:pPr>
             <a:r>
-              <a:rPr lang="en-US" sz="4000" b="1" dirty="0">
+              <a:rPr lang="en-US" sz="4000" dirty="0">
                 <a:solidFill>
                   <a:srgbClr val="111111"/>
                 </a:solidFill>
@@ -14674,27 +14920,7 @@
                 <a:ea typeface="Times New Roman" pitchFamily="34" charset="-122"/>
                 <a:cs typeface="Times New Roman" pitchFamily="34" charset="-120"/>
               </a:rPr>
-              <a:t>Our next lesson will be on:</a:t>
-            </a:r>
-            <a:endParaRPr lang="en-US" sz="4000" dirty="0"/>
-          </a:p>
-          <a:p>
-            <a:pPr algn="ctr" indent="0" marL="0">
-              <a:spcAft>
-                <a:spcPts val="800"/>
-              </a:spcAft>
-              <a:buNone/>
-            </a:pPr>
-            <a:r>
-              <a:rPr lang="en-US" sz="4000" b="1" dirty="0">
-                <a:solidFill>
-                  <a:srgbClr val="990011"/>
-                </a:solidFill>
-                <a:latin typeface="Times New Roman" pitchFamily="34" charset="0"/>
-                <a:ea typeface="Times New Roman" pitchFamily="34" charset="-122"/>
-                <a:cs typeface="Times New Roman" pitchFamily="34" charset="-120"/>
-              </a:rPr>
-              <a:t>Lesson 15: Weathering</a:t>
+              <a:t>Weathering, erosion, transport and deposition.</a:t>
             </a:r>
             <a:endParaRPr lang="en-US" sz="4000" dirty="0"/>
           </a:p>
@@ -14806,6 +15032,749 @@
                 <a:ea typeface="Calibri" pitchFamily="34" charset="-122"/>
                 <a:cs typeface="Calibri" pitchFamily="34" charset="-120"/>
               </a:rPr>
+              <a:t>REMEDIATION</a:t>
+            </a:r>
+            <a:endParaRPr lang="en-US" sz="1400" dirty="0"/>
+          </a:p>
+        </p:txBody>
+      </p:sp>
+      <p:pic>
+        <p:nvPicPr>
+          <p:cNvPr id="3" name="Image 0" descr="/home/claude/f4/img/minesec_sheet.png">    </p:cNvPr>
+          <p:cNvPicPr>
+            <a:picLocks noChangeAspect="1"/>
+          </p:cNvPicPr>
+          <p:nvPr/>
+        </p:nvPicPr>
+        <p:blipFill>
+          <a:blip r:embed="rId1"/>
+          <a:stretch>
+            <a:fillRect/>
+          </a:stretch>
+        </p:blipFill>
+        <p:spPr>
+          <a:xfrm>
+            <a:off x="0" y="658368"/>
+            <a:ext cx="2468880" cy="5833872"/>
+          </a:xfrm>
+          <a:prstGeom prst="rect">
+            <a:avLst/>
+          </a:prstGeom>
+        </p:spPr>
+      </p:pic>
+      <p:sp>
+        <p:nvSpPr>
+          <p:cNvPr id="4" name="Text 1"/>
+          <p:cNvSpPr/>
+          <p:nvPr/>
+        </p:nvSpPr>
+        <p:spPr>
+          <a:xfrm>
+            <a:off x="2697480" y="1005840"/>
+            <a:ext cx="9174175" cy="731520"/>
+          </a:xfrm>
+          <a:prstGeom prst="rect">
+            <a:avLst/>
+          </a:prstGeom>
+          <a:noFill/>
+          <a:ln/>
+        </p:spPr>
+        <p:txBody>
+          <a:bodyPr wrap="square" lIns="0" tIns="0" rIns="0" bIns="0" rtlCol="0" anchor="ctr">
+            <a:normAutofit/>
+          </a:bodyPr>
+          <a:lstStyle/>
+          <a:p>
+            <a:pPr algn="ctr" indent="0" marL="0">
+              <a:buNone/>
+            </a:pPr>
+            <a:r>
+              <a:rPr lang="en-US" sz="3600" b="1" dirty="0">
+                <a:solidFill>
+                  <a:srgbClr val="990011"/>
+                </a:solidFill>
+                <a:latin typeface="Times New Roman" pitchFamily="34" charset="0"/>
+                <a:ea typeface="Times New Roman" pitchFamily="34" charset="-122"/>
+                <a:cs typeface="Times New Roman" pitchFamily="34" charset="-120"/>
+              </a:rPr>
+              <a:t>Remediation</a:t>
+            </a:r>
+            <a:endParaRPr lang="en-US" sz="3600" dirty="0"/>
+          </a:p>
+        </p:txBody>
+      </p:sp>
+      <p:sp>
+        <p:nvSpPr>
+          <p:cNvPr id="5" name="Text 2"/>
+          <p:cNvSpPr/>
+          <p:nvPr/>
+        </p:nvSpPr>
+        <p:spPr>
+          <a:xfrm>
+            <a:off x="2697480" y="1783080"/>
+            <a:ext cx="9174175" cy="4663440"/>
+          </a:xfrm>
+          <a:prstGeom prst="rect">
+            <a:avLst/>
+          </a:prstGeom>
+          <a:noFill/>
+          <a:ln/>
+        </p:spPr>
+        <p:txBody>
+          <a:bodyPr wrap="square" lIns="0" tIns="0" rIns="0" bIns="0" rtlCol="0" anchor="t"/>
+          <a:lstStyle/>
+          <a:p>
+            <a:pPr algn="l" indent="0" marL="0">
+              <a:spcAft>
+                <a:spcPts val="800"/>
+              </a:spcAft>
+              <a:buNone/>
+            </a:pPr>
+            <a:r>
+              <a:rPr lang="en-US" sz="4000" b="1" dirty="0">
+                <a:solidFill>
+                  <a:srgbClr val="111111"/>
+                </a:solidFill>
+                <a:latin typeface="Times New Roman" pitchFamily="34" charset="0"/>
+                <a:ea typeface="Times New Roman" pitchFamily="34" charset="-122"/>
+                <a:cs typeface="Times New Roman" pitchFamily="34" charset="-120"/>
+              </a:rPr>
+              <a:t>Fill in the blanks:</a:t>
+            </a:r>
+            <a:endParaRPr lang="en-US" sz="4000" dirty="0"/>
+          </a:p>
+          <a:p>
+            <a:pPr algn="l" marL="342900" indent="-342900">
+              <a:spcAft>
+                <a:spcPts val="800"/>
+              </a:spcAft>
+              <a:buSzPct val="100000"/>
+              <a:buFont typeface="+mj-lt"/>
+              <a:buAutoNum type="arabicPeriod" startAt="1"/>
+            </a:pPr>
+            <a:r>
+              <a:rPr lang="en-US" sz="4000" dirty="0">
+                <a:solidFill>
+                  <a:srgbClr val="111111"/>
+                </a:solidFill>
+                <a:latin typeface="Times New Roman" pitchFamily="34" charset="0"/>
+                <a:ea typeface="Times New Roman" pitchFamily="34" charset="-122"/>
+                <a:cs typeface="Times New Roman" pitchFamily="34" charset="-120"/>
+              </a:rPr>
+              <a:t>The breaking of rocks in their place is ______.</a:t>
+            </a:r>
+            <a:endParaRPr lang="en-US" sz="4000" dirty="0"/>
+          </a:p>
+          <a:p>
+            <a:pPr algn="l" marL="342900" indent="-342900">
+              <a:spcAft>
+                <a:spcPts val="800"/>
+              </a:spcAft>
+              <a:buSzPct val="100000"/>
+              <a:buFont typeface="+mj-lt"/>
+              <a:buAutoNum type="arabicPeriod" startAt="1"/>
+            </a:pPr>
+            <a:r>
+              <a:rPr lang="en-US" sz="4000" dirty="0">
+                <a:solidFill>
+                  <a:srgbClr val="111111"/>
+                </a:solidFill>
+                <a:latin typeface="Times New Roman" pitchFamily="34" charset="0"/>
+                <a:ea typeface="Times New Roman" pitchFamily="34" charset="-122"/>
+                <a:cs typeface="Times New Roman" pitchFamily="34" charset="-120"/>
+              </a:rPr>
+              <a:t>The dropping of material is ______.</a:t>
+            </a:r>
+            <a:endParaRPr lang="en-US" sz="4000" dirty="0"/>
+          </a:p>
+          <a:p>
+            <a:pPr algn="l" marL="342900" indent="-342900">
+              <a:spcAft>
+                <a:spcPts val="800"/>
+              </a:spcAft>
+              <a:buSzPct val="100000"/>
+              <a:buFont typeface="+mj-lt"/>
+              <a:buAutoNum type="arabicPeriod" startAt="1"/>
+            </a:pPr>
+            <a:r>
+              <a:rPr lang="en-US" sz="4000" dirty="0">
+                <a:solidFill>
+                  <a:srgbClr val="111111"/>
+                </a:solidFill>
+                <a:latin typeface="Times New Roman" pitchFamily="34" charset="0"/>
+                <a:ea typeface="Times New Roman" pitchFamily="34" charset="-122"/>
+                <a:cs typeface="Times New Roman" pitchFamily="34" charset="-120"/>
+              </a:rPr>
+              <a:t>The most important agent of denudation is running ______.</a:t>
+            </a:r>
+            <a:endParaRPr lang="en-US" sz="4000" dirty="0"/>
+          </a:p>
+        </p:txBody>
+      </p:sp>
+      <p:sp>
+        <p:nvSpPr>
+          <p:cNvPr id="25" name="Slide Number Placeholder 0"/>
+          <p:cNvSpPr>
+            <a:spLocks noGrp="1"/>
+          </p:cNvSpPr>
+          <p:nvPr>
+            <p:ph type="sldNum" sz="quarter" idx="4294967295"/>
+          </p:nvPr>
+        </p:nvSpPr>
+        <p:spPr>
+          <a:xfrm>
+            <a:off x="27432" y="91440"/>
+            <a:ext cx="585216" cy="475488"/>
+          </a:xfrm>
+          <a:prstGeom prst="rect">
+            <a:avLst/>
+          </a:prstGeom>
+          <a:extLst>
+            <a:ext uri="{C572A759-6A51-4108-AA02-DFA0A04FC94B}">
+              <ma14:wrappingTextBoxFlag xmlns:ma14="http://schemas.microsoft.com/office/mac/drawingml/2011/main" val="0"/>
+            </a:ext>
+          </a:extLst>
+        </p:spPr>
+        <p:txBody>
+          <a:bodyPr/>
+          <a:lstStyle>
+            <a:lvl1pPr>
+              <a:defRPr sz="2000">
+                <a:solidFill>
+                  <a:srgbClr val="FFFFFF"/>
+                </a:solidFill>
+                <a:latin typeface="Calibri"/>
+                <a:ea typeface="Calibri"/>
+                <a:cs typeface="Calibri"/>
+              </a:defRPr>
+            </a:lvl1pPr>
+          </a:lstStyle>
+          <a:p>
+            <a:pPr algn="ctr"/>
+            <a:fld id="{F7021451-1387-4CA6-816F-3879F97B5CBC}" type="slidenum">
+              <a:rPr b="1" lang="en-US"/>
+              <a:t>41</a:t>
+            </a:fld>
+            <a:endParaRPr lang="en-US"/>
+          </a:p>
+        </p:txBody>
+      </p:sp>
+    </p:spTree>
+  </p:cSld>
+  <p:clrMapOvr>
+    <a:masterClrMapping/>
+  </p:clrMapOvr>
+</p:sld>
+</file>
+
+<file path=ppt/slides/slide42.xml><?xml version="1.0" encoding="utf-8"?>
+<p:sld xmlns:a="http://schemas.openxmlformats.org/drawingml/2006/main" xmlns:r="http://schemas.openxmlformats.org/officeDocument/2006/relationships" xmlns:p="http://schemas.openxmlformats.org/presentationml/2006/main">
+  <p:cSld name="Slide 42">
+    <p:spTree>
+      <p:nvGrpSpPr>
+        <p:cNvPr id="1" name=""/>
+        <p:cNvGrpSpPr/>
+        <p:nvPr/>
+      </p:nvGrpSpPr>
+      <p:grpSpPr>
+        <a:xfrm>
+          <a:off x="0" y="0"/>
+          <a:ext cx="0" cy="0"/>
+          <a:chOff x="0" y="0"/>
+          <a:chExt cx="0" cy="0"/>
+        </a:xfrm>
+      </p:grpSpPr>
+      <p:sp>
+        <p:nvSpPr>
+          <p:cNvPr id="2" name="Text 0"/>
+          <p:cNvSpPr/>
+          <p:nvPr/>
+        </p:nvSpPr>
+        <p:spPr>
+          <a:xfrm>
+            <a:off x="457200" y="713232"/>
+            <a:ext cx="11368735" cy="274320"/>
+          </a:xfrm>
+          <a:prstGeom prst="rect">
+            <a:avLst/>
+          </a:prstGeom>
+          <a:noFill/>
+          <a:ln/>
+        </p:spPr>
+        <p:txBody>
+          <a:bodyPr wrap="square" lIns="0" tIns="0" rIns="0" bIns="0" rtlCol="0" anchor="ctr"/>
+          <a:lstStyle/>
+          <a:p>
+            <a:pPr algn="r" indent="0" marL="0">
+              <a:buNone/>
+            </a:pPr>
+            <a:r>
+              <a:rPr lang="en-US" sz="1400" b="1" dirty="0">
+                <a:solidFill>
+                  <a:srgbClr val="1C3F6E"/>
+                </a:solidFill>
+                <a:latin typeface="Calibri" pitchFamily="34" charset="0"/>
+                <a:ea typeface="Calibri" pitchFamily="34" charset="-122"/>
+                <a:cs typeface="Calibri" pitchFamily="34" charset="-120"/>
+              </a:rPr>
+              <a:t>HOMEWORK</a:t>
+            </a:r>
+            <a:endParaRPr lang="en-US" sz="1400" dirty="0"/>
+          </a:p>
+        </p:txBody>
+      </p:sp>
+      <p:pic>
+        <p:nvPicPr>
+          <p:cNvPr id="3" name="Image 0" descr="/home/claude/f4/img/minesec_sheet.png">    </p:cNvPr>
+          <p:cNvPicPr>
+            <a:picLocks noChangeAspect="1"/>
+          </p:cNvPicPr>
+          <p:nvPr/>
+        </p:nvPicPr>
+        <p:blipFill>
+          <a:blip r:embed="rId1"/>
+          <a:stretch>
+            <a:fillRect/>
+          </a:stretch>
+        </p:blipFill>
+        <p:spPr>
+          <a:xfrm>
+            <a:off x="0" y="658368"/>
+            <a:ext cx="5120640" cy="5833872"/>
+          </a:xfrm>
+          <a:prstGeom prst="rect">
+            <a:avLst/>
+          </a:prstGeom>
+        </p:spPr>
+      </p:pic>
+      <p:sp>
+        <p:nvSpPr>
+          <p:cNvPr id="4" name="Text 1"/>
+          <p:cNvSpPr/>
+          <p:nvPr/>
+        </p:nvSpPr>
+        <p:spPr>
+          <a:xfrm>
+            <a:off x="5349240" y="1005840"/>
+            <a:ext cx="6522415" cy="731520"/>
+          </a:xfrm>
+          <a:prstGeom prst="rect">
+            <a:avLst/>
+          </a:prstGeom>
+          <a:noFill/>
+          <a:ln/>
+        </p:spPr>
+        <p:txBody>
+          <a:bodyPr wrap="square" lIns="0" tIns="0" rIns="0" bIns="0" rtlCol="0" anchor="ctr">
+            <a:normAutofit/>
+          </a:bodyPr>
+          <a:lstStyle/>
+          <a:p>
+            <a:pPr algn="ctr" indent="0" marL="0">
+              <a:buNone/>
+            </a:pPr>
+            <a:r>
+              <a:rPr lang="en-US" sz="3600" b="1" dirty="0">
+                <a:solidFill>
+                  <a:srgbClr val="990011"/>
+                </a:solidFill>
+                <a:latin typeface="Times New Roman" pitchFamily="34" charset="0"/>
+                <a:ea typeface="Times New Roman" pitchFamily="34" charset="-122"/>
+                <a:cs typeface="Times New Roman" pitchFamily="34" charset="-120"/>
+              </a:rPr>
+              <a:t>Homework</a:t>
+            </a:r>
+            <a:endParaRPr lang="en-US" sz="3600" dirty="0"/>
+          </a:p>
+        </p:txBody>
+      </p:sp>
+      <p:sp>
+        <p:nvSpPr>
+          <p:cNvPr id="5" name="Text 2"/>
+          <p:cNvSpPr/>
+          <p:nvPr/>
+        </p:nvSpPr>
+        <p:spPr>
+          <a:xfrm>
+            <a:off x="5349240" y="1783080"/>
+            <a:ext cx="6522415" cy="4663440"/>
+          </a:xfrm>
+          <a:prstGeom prst="rect">
+            <a:avLst/>
+          </a:prstGeom>
+          <a:noFill/>
+          <a:ln/>
+        </p:spPr>
+        <p:txBody>
+          <a:bodyPr wrap="square" lIns="0" tIns="0" rIns="0" bIns="0" rtlCol="0" anchor="t"/>
+          <a:lstStyle/>
+          <a:p>
+            <a:pPr algn="l" indent="0" marL="0">
+              <a:spcAft>
+                <a:spcPts val="800"/>
+              </a:spcAft>
+              <a:buNone/>
+            </a:pPr>
+            <a:r>
+              <a:rPr lang="en-US" sz="4000" dirty="0">
+                <a:solidFill>
+                  <a:srgbClr val="111111"/>
+                </a:solidFill>
+                <a:latin typeface="Times New Roman" pitchFamily="34" charset="0"/>
+                <a:ea typeface="Times New Roman" pitchFamily="34" charset="-122"/>
+                <a:cs typeface="Times New Roman" pitchFamily="34" charset="-120"/>
+              </a:rPr>
+              <a:t>Compare an old wall and a new wall in your area. Write three differences you see, and suggest what damaged the old wall.</a:t>
+            </a:r>
+            <a:endParaRPr lang="en-US" sz="4000" dirty="0"/>
+          </a:p>
+        </p:txBody>
+      </p:sp>
+      <p:sp>
+        <p:nvSpPr>
+          <p:cNvPr id="25" name="Slide Number Placeholder 0"/>
+          <p:cNvSpPr>
+            <a:spLocks noGrp="1"/>
+          </p:cNvSpPr>
+          <p:nvPr>
+            <p:ph type="sldNum" sz="quarter" idx="4294967295"/>
+          </p:nvPr>
+        </p:nvSpPr>
+        <p:spPr>
+          <a:xfrm>
+            <a:off x="27432" y="91440"/>
+            <a:ext cx="585216" cy="475488"/>
+          </a:xfrm>
+          <a:prstGeom prst="rect">
+            <a:avLst/>
+          </a:prstGeom>
+          <a:extLst>
+            <a:ext uri="{C572A759-6A51-4108-AA02-DFA0A04FC94B}">
+              <ma14:wrappingTextBoxFlag xmlns:ma14="http://schemas.microsoft.com/office/mac/drawingml/2011/main" val="0"/>
+            </a:ext>
+          </a:extLst>
+        </p:spPr>
+        <p:txBody>
+          <a:bodyPr/>
+          <a:lstStyle>
+            <a:lvl1pPr>
+              <a:defRPr sz="2000">
+                <a:solidFill>
+                  <a:srgbClr val="FFFFFF"/>
+                </a:solidFill>
+                <a:latin typeface="Calibri"/>
+                <a:ea typeface="Calibri"/>
+                <a:cs typeface="Calibri"/>
+              </a:defRPr>
+            </a:lvl1pPr>
+          </a:lstStyle>
+          <a:p>
+            <a:pPr algn="ctr"/>
+            <a:fld id="{F7021451-1387-4CA6-816F-3879F97B5CBC}" type="slidenum">
+              <a:rPr b="1" lang="en-US"/>
+              <a:t>42</a:t>
+            </a:fld>
+            <a:endParaRPr lang="en-US"/>
+          </a:p>
+        </p:txBody>
+      </p:sp>
+    </p:spTree>
+  </p:cSld>
+  <p:clrMapOvr>
+    <a:masterClrMapping/>
+  </p:clrMapOvr>
+</p:sld>
+</file>
+
+<file path=ppt/slides/slide43.xml><?xml version="1.0" encoding="utf-8"?>
+<p:sld xmlns:a="http://schemas.openxmlformats.org/drawingml/2006/main" xmlns:r="http://schemas.openxmlformats.org/officeDocument/2006/relationships" xmlns:p="http://schemas.openxmlformats.org/presentationml/2006/main">
+  <p:cSld name="Slide 43">
+    <p:spTree>
+      <p:nvGrpSpPr>
+        <p:cNvPr id="1" name=""/>
+        <p:cNvGrpSpPr/>
+        <p:nvPr/>
+      </p:nvGrpSpPr>
+      <p:grpSpPr>
+        <a:xfrm>
+          <a:off x="0" y="0"/>
+          <a:ext cx="0" cy="0"/>
+          <a:chOff x="0" y="0"/>
+          <a:chExt cx="0" cy="0"/>
+        </a:xfrm>
+      </p:grpSpPr>
+      <p:sp>
+        <p:nvSpPr>
+          <p:cNvPr id="2" name="Text 0"/>
+          <p:cNvSpPr/>
+          <p:nvPr/>
+        </p:nvSpPr>
+        <p:spPr>
+          <a:xfrm>
+            <a:off x="457200" y="713232"/>
+            <a:ext cx="11368735" cy="274320"/>
+          </a:xfrm>
+          <a:prstGeom prst="rect">
+            <a:avLst/>
+          </a:prstGeom>
+          <a:noFill/>
+          <a:ln/>
+        </p:spPr>
+        <p:txBody>
+          <a:bodyPr wrap="square" lIns="0" tIns="0" rIns="0" bIns="0" rtlCol="0" anchor="ctr"/>
+          <a:lstStyle/>
+          <a:p>
+            <a:pPr algn="r" indent="0" marL="0">
+              <a:buNone/>
+            </a:pPr>
+            <a:r>
+              <a:rPr lang="en-US" sz="1400" b="1" dirty="0">
+                <a:solidFill>
+                  <a:srgbClr val="1C3F6E"/>
+                </a:solidFill>
+                <a:latin typeface="Calibri" pitchFamily="34" charset="0"/>
+                <a:ea typeface="Calibri" pitchFamily="34" charset="-122"/>
+                <a:cs typeface="Calibri" pitchFamily="34" charset="-120"/>
+              </a:rPr>
+              <a:t>NEXT LESSON</a:t>
+            </a:r>
+            <a:endParaRPr lang="en-US" sz="1400" dirty="0"/>
+          </a:p>
+        </p:txBody>
+      </p:sp>
+      <p:pic>
+        <p:nvPicPr>
+          <p:cNvPr id="3" name="Image 0" descr="/home/claude/f4/img/minesec_sheet.png">    </p:cNvPr>
+          <p:cNvPicPr>
+            <a:picLocks noChangeAspect="1"/>
+          </p:cNvPicPr>
+          <p:nvPr/>
+        </p:nvPicPr>
+        <p:blipFill>
+          <a:blip r:embed="rId1"/>
+          <a:stretch>
+            <a:fillRect/>
+          </a:stretch>
+        </p:blipFill>
+        <p:spPr>
+          <a:xfrm>
+            <a:off x="0" y="658368"/>
+            <a:ext cx="5120640" cy="5833872"/>
+          </a:xfrm>
+          <a:prstGeom prst="rect">
+            <a:avLst/>
+          </a:prstGeom>
+        </p:spPr>
+      </p:pic>
+      <p:sp>
+        <p:nvSpPr>
+          <p:cNvPr id="4" name="Text 1"/>
+          <p:cNvSpPr/>
+          <p:nvPr/>
+        </p:nvSpPr>
+        <p:spPr>
+          <a:xfrm>
+            <a:off x="5349240" y="1005840"/>
+            <a:ext cx="6522415" cy="731520"/>
+          </a:xfrm>
+          <a:prstGeom prst="rect">
+            <a:avLst/>
+          </a:prstGeom>
+          <a:noFill/>
+          <a:ln/>
+        </p:spPr>
+        <p:txBody>
+          <a:bodyPr wrap="square" lIns="0" tIns="0" rIns="0" bIns="0" rtlCol="0" anchor="ctr">
+            <a:normAutofit/>
+          </a:bodyPr>
+          <a:lstStyle/>
+          <a:p>
+            <a:pPr algn="ctr" indent="0" marL="0">
+              <a:buNone/>
+            </a:pPr>
+            <a:r>
+              <a:rPr lang="en-US" sz="3600" b="1" dirty="0">
+                <a:solidFill>
+                  <a:srgbClr val="990011"/>
+                </a:solidFill>
+                <a:latin typeface="Times New Roman" pitchFamily="34" charset="0"/>
+                <a:ea typeface="Times New Roman" pitchFamily="34" charset="-122"/>
+                <a:cs typeface="Times New Roman" pitchFamily="34" charset="-120"/>
+              </a:rPr>
+              <a:t>Next Lesson</a:t>
+            </a:r>
+            <a:endParaRPr lang="en-US" sz="3600" dirty="0"/>
+          </a:p>
+        </p:txBody>
+      </p:sp>
+      <p:sp>
+        <p:nvSpPr>
+          <p:cNvPr id="5" name="Text 2"/>
+          <p:cNvSpPr/>
+          <p:nvPr/>
+        </p:nvSpPr>
+        <p:spPr>
+          <a:xfrm>
+            <a:off x="5349240" y="1783080"/>
+            <a:ext cx="6522415" cy="4663440"/>
+          </a:xfrm>
+          <a:prstGeom prst="rect">
+            <a:avLst/>
+          </a:prstGeom>
+          <a:noFill/>
+          <a:ln/>
+        </p:spPr>
+        <p:txBody>
+          <a:bodyPr wrap="square" lIns="0" tIns="0" rIns="0" bIns="0" rtlCol="0" anchor="ctr"/>
+          <a:lstStyle/>
+          <a:p>
+            <a:pPr algn="ctr" indent="0" marL="0">
+              <a:spcAft>
+                <a:spcPts val="800"/>
+              </a:spcAft>
+              <a:buNone/>
+            </a:pPr>
+            <a:r>
+              <a:rPr lang="en-US" sz="4000" b="1" dirty="0">
+                <a:solidFill>
+                  <a:srgbClr val="111111"/>
+                </a:solidFill>
+                <a:latin typeface="Times New Roman" pitchFamily="34" charset="0"/>
+                <a:ea typeface="Times New Roman" pitchFamily="34" charset="-122"/>
+                <a:cs typeface="Times New Roman" pitchFamily="34" charset="-120"/>
+              </a:rPr>
+              <a:t>Our next lesson will be on:</a:t>
+            </a:r>
+            <a:endParaRPr lang="en-US" sz="4000" dirty="0"/>
+          </a:p>
+          <a:p>
+            <a:pPr algn="ctr" indent="0" marL="0">
+              <a:spcAft>
+                <a:spcPts val="800"/>
+              </a:spcAft>
+              <a:buNone/>
+            </a:pPr>
+            <a:r>
+              <a:rPr lang="en-US" sz="4000" b="1" dirty="0">
+                <a:solidFill>
+                  <a:srgbClr val="990011"/>
+                </a:solidFill>
+                <a:latin typeface="Times New Roman" pitchFamily="34" charset="0"/>
+                <a:ea typeface="Times New Roman" pitchFamily="34" charset="-122"/>
+                <a:cs typeface="Times New Roman" pitchFamily="34" charset="-120"/>
+              </a:rPr>
+              <a:t>Lesson 15: Weathering</a:t>
+            </a:r>
+            <a:endParaRPr lang="en-US" sz="4000" dirty="0"/>
+          </a:p>
+        </p:txBody>
+      </p:sp>
+      <p:sp>
+        <p:nvSpPr>
+          <p:cNvPr id="25" name="Slide Number Placeholder 0"/>
+          <p:cNvSpPr>
+            <a:spLocks noGrp="1"/>
+          </p:cNvSpPr>
+          <p:nvPr>
+            <p:ph type="sldNum" sz="quarter" idx="4294967295"/>
+          </p:nvPr>
+        </p:nvSpPr>
+        <p:spPr>
+          <a:xfrm>
+            <a:off x="27432" y="91440"/>
+            <a:ext cx="585216" cy="475488"/>
+          </a:xfrm>
+          <a:prstGeom prst="rect">
+            <a:avLst/>
+          </a:prstGeom>
+          <a:extLst>
+            <a:ext uri="{C572A759-6A51-4108-AA02-DFA0A04FC94B}">
+              <ma14:wrappingTextBoxFlag xmlns:ma14="http://schemas.microsoft.com/office/mac/drawingml/2011/main" val="0"/>
+            </a:ext>
+          </a:extLst>
+        </p:spPr>
+        <p:txBody>
+          <a:bodyPr/>
+          <a:lstStyle>
+            <a:lvl1pPr>
+              <a:defRPr sz="2000">
+                <a:solidFill>
+                  <a:srgbClr val="FFFFFF"/>
+                </a:solidFill>
+                <a:latin typeface="Calibri"/>
+                <a:ea typeface="Calibri"/>
+                <a:cs typeface="Calibri"/>
+              </a:defRPr>
+            </a:lvl1pPr>
+          </a:lstStyle>
+          <a:p>
+            <a:pPr algn="ctr"/>
+            <a:fld id="{F7021451-1387-4CA6-816F-3879F97B5CBC}" type="slidenum">
+              <a:rPr b="1" lang="en-US"/>
+              <a:t>43</a:t>
+            </a:fld>
+            <a:endParaRPr lang="en-US"/>
+          </a:p>
+        </p:txBody>
+      </p:sp>
+    </p:spTree>
+  </p:cSld>
+  <p:clrMapOvr>
+    <a:masterClrMapping/>
+  </p:clrMapOvr>
+</p:sld>
+</file>
+
+<file path=ppt/slides/slide44.xml><?xml version="1.0" encoding="utf-8"?>
+<p:sld xmlns:a="http://schemas.openxmlformats.org/drawingml/2006/main" xmlns:r="http://schemas.openxmlformats.org/officeDocument/2006/relationships" xmlns:p="http://schemas.openxmlformats.org/presentationml/2006/main">
+  <p:cSld name="Slide 44">
+    <p:spTree>
+      <p:nvGrpSpPr>
+        <p:cNvPr id="1" name=""/>
+        <p:cNvGrpSpPr/>
+        <p:nvPr/>
+      </p:nvGrpSpPr>
+      <p:grpSpPr>
+        <a:xfrm>
+          <a:off x="0" y="0"/>
+          <a:ext cx="0" cy="0"/>
+          <a:chOff x="0" y="0"/>
+          <a:chExt cx="0" cy="0"/>
+        </a:xfrm>
+      </p:grpSpPr>
+      <p:sp>
+        <p:nvSpPr>
+          <p:cNvPr id="2" name="Text 0"/>
+          <p:cNvSpPr/>
+          <p:nvPr/>
+        </p:nvSpPr>
+        <p:spPr>
+          <a:xfrm>
+            <a:off x="457200" y="713232"/>
+            <a:ext cx="11368735" cy="274320"/>
+          </a:xfrm>
+          <a:prstGeom prst="rect">
+            <a:avLst/>
+          </a:prstGeom>
+          <a:noFill/>
+          <a:ln/>
+        </p:spPr>
+        <p:txBody>
+          <a:bodyPr wrap="square" lIns="0" tIns="0" rIns="0" bIns="0" rtlCol="0" anchor="ctr"/>
+          <a:lstStyle/>
+          <a:p>
+            <a:pPr algn="r" indent="0" marL="0">
+              <a:buNone/>
+            </a:pPr>
+            <a:r>
+              <a:rPr lang="en-US" sz="1400" b="1" dirty="0">
+                <a:solidFill>
+                  <a:srgbClr val="1C3F6E"/>
+                </a:solidFill>
+                <a:latin typeface="Calibri" pitchFamily="34" charset="0"/>
+                <a:ea typeface="Calibri" pitchFamily="34" charset="-122"/>
+                <a:cs typeface="Calibri" pitchFamily="34" charset="-120"/>
+              </a:rPr>
               <a:t>BILINGUAL GAME</a:t>
             </a:r>
             <a:endParaRPr lang="en-US" sz="1400" dirty="0"/>
@@ -14853,7 +15822,7 @@
       </p:sp>
       <p:graphicFrame>
         <p:nvGraphicFramePr>
-          <p:cNvPr id="42" name="Table 0"/>
+          <p:cNvPr id="45" name="Table 0"/>
           <p:cNvGraphicFramePr>
             <a:graphicFrameLocks noGrp="1"/>
           </p:cNvGraphicFramePr>
@@ -16165,7 +17134,7 @@
             <a:pPr algn="ctr"/>
             <a:fld id="{F7021451-1387-4CA6-816F-3879F97B5CBC}" type="slidenum">
               <a:rPr b="1" lang="en-US"/>
-              <a:t>41</a:t>
+              <a:t>44</a:t>
             </a:fld>
             <a:endParaRPr lang="en-US"/>
           </a:p>
@@ -16179,9 +17148,9 @@
 </p:sld>
 </file>
 
-<file path=ppt/slides/slide42.xml><?xml version="1.0" encoding="utf-8"?>
+<file path=ppt/slides/slide45.xml><?xml version="1.0" encoding="utf-8"?>
 <p:sld xmlns:a="http://schemas.openxmlformats.org/drawingml/2006/main" xmlns:r="http://schemas.openxmlformats.org/officeDocument/2006/relationships" xmlns:p="http://schemas.openxmlformats.org/presentationml/2006/main">
-  <p:cSld name="Slide 42">
+  <p:cSld name="Slide 45">
     <p:spTree>
       <p:nvGrpSpPr>
         <p:cNvPr id="1" name=""/>
@@ -16276,7 +17245,7 @@
       </p:sp>
       <p:graphicFrame>
         <p:nvGraphicFramePr>
-          <p:cNvPr id="43" name="Table 0"/>
+          <p:cNvPr id="46" name="Table 0"/>
           <p:cNvGraphicFramePr>
             <a:graphicFrameLocks noGrp="1"/>
           </p:cNvGraphicFramePr>
@@ -16898,7 +17867,7 @@
             <a:pPr algn="ctr"/>
             <a:fld id="{F7021451-1387-4CA6-816F-3879F97B5CBC}" type="slidenum">
               <a:rPr b="1" lang="en-US"/>
-              <a:t>42</a:t>
+              <a:t>45</a:t>
             </a:fld>
             <a:endParaRPr lang="en-US"/>
           </a:p>
@@ -16912,9 +17881,9 @@
 </p:sld>
 </file>
 
-<file path=ppt/slides/slide43.xml><?xml version="1.0" encoding="utf-8"?>
+<file path=ppt/slides/slide46.xml><?xml version="1.0" encoding="utf-8"?>
 <p:sld xmlns:a="http://schemas.openxmlformats.org/drawingml/2006/main" xmlns:r="http://schemas.openxmlformats.org/officeDocument/2006/relationships" xmlns:p="http://schemas.openxmlformats.org/presentationml/2006/main">
-  <p:cSld name="Slide 43">
+  <p:cSld name="Slide 46">
     <p:spTree>
       <p:nvGrpSpPr>
         <p:cNvPr id="1" name=""/>
@@ -17009,7 +17978,7 @@
       </p:sp>
       <p:graphicFrame>
         <p:nvGraphicFramePr>
-          <p:cNvPr id="44" name="Table 0"/>
+          <p:cNvPr id="47" name="Table 0"/>
           <p:cNvGraphicFramePr>
             <a:graphicFrameLocks noGrp="1"/>
           </p:cNvGraphicFramePr>
@@ -17119,7 +18088,7 @@
                           <a:ea typeface="Calibri" pitchFamily="34" charset="-122"/>
                           <a:cs typeface="Calibri" pitchFamily="34" charset="-120"/>
                         </a:rPr>
-                        <a:t>Meaning of Denudation; Processes of Denudation; Agents of Denudation.</a:t>
+                        <a:t>DEFINITIONS; Major Processes of Denudation; Main Agents of Denudation.</a:t>
                       </a:r>
                       <a:endParaRPr lang="en-US" sz="1600" dirty="0">
                         <a:latin typeface="Calibri" charset="0"/>
@@ -17769,7 +18738,7 @@
             <a:pPr algn="ctr"/>
             <a:fld id="{F7021451-1387-4CA6-816F-3879F97B5CBC}" type="slidenum">
               <a:rPr b="1" lang="en-US"/>
-              <a:t>43</a:t>
+              <a:t>46</a:t>
             </a:fld>
             <a:endParaRPr lang="en-US"/>
           </a:p>
@@ -17783,9 +18752,9 @@
 </p:sld>
 </file>
 
-<file path=ppt/slides/slide44.xml><?xml version="1.0" encoding="utf-8"?>
+<file path=ppt/slides/slide47.xml><?xml version="1.0" encoding="utf-8"?>
 <p:sld xmlns:a="http://schemas.openxmlformats.org/drawingml/2006/main" xmlns:r="http://schemas.openxmlformats.org/officeDocument/2006/relationships" xmlns:p="http://schemas.openxmlformats.org/presentationml/2006/main">
-  <p:cSld name="Slide 44">
+  <p:cSld name="Slide 47">
     <p:spTree>
       <p:nvGrpSpPr>
         <p:cNvPr id="1" name=""/>
@@ -17983,7 +18952,7 @@
                 <a:ea typeface="Calibri" pitchFamily="34" charset="-122"/>
                 <a:cs typeface="Calibri" pitchFamily="34" charset="-120"/>
               </a:rPr>
-              <a:t>Without the projector (Activity 1): describe the channels beside the roads after a storm.</a:t>
+              <a:t>Without the projector (Activity 1): describe a road side after a storm.</a:t>
             </a:r>
             <a:endParaRPr lang="en-US" sz="2000" dirty="0"/>
           </a:p>
@@ -18004,7 +18973,7 @@
                 <a:ea typeface="Calibri" pitchFamily="34" charset="-122"/>
                 <a:cs typeface="Calibri" pitchFamily="34" charset="-120"/>
               </a:rPr>
-              <a:t>Without the projector (Activity 2): write the four words with arrows on the board.</a:t>
+              <a:t>Without the projector (Activity 2): write the processes in boxes on the board.</a:t>
             </a:r>
             <a:endParaRPr lang="en-US" sz="2000" dirty="0"/>
           </a:p>
@@ -18025,7 +18994,7 @@
                 <a:ea typeface="Calibri" pitchFamily="34" charset="-122"/>
                 <a:cs typeface="Calibri" pitchFamily="34" charset="-120"/>
               </a:rPr>
-              <a:t>Without the projector (Activity 3): compare the Benue in August and in March.</a:t>
+              <a:t>Without the projector (Activity 3): describe the Benue in the rainy season.</a:t>
             </a:r>
             <a:endParaRPr lang="en-US" sz="2000" dirty="0"/>
           </a:p>
@@ -18073,7 +19042,7 @@
             <a:pPr algn="ctr"/>
             <a:fld id="{F7021451-1387-4CA6-816F-3879F97B5CBC}" type="slidenum">
               <a:rPr b="1" lang="en-US"/>
-              <a:t>44</a:t>
+              <a:t>47</a:t>
             </a:fld>
             <a:endParaRPr lang="en-US"/>
           </a:p>
@@ -18087,9 +19056,9 @@
 </p:sld>
 </file>
 
-<file path=ppt/slides/slide45.xml><?xml version="1.0" encoding="utf-8"?>
+<file path=ppt/slides/slide48.xml><?xml version="1.0" encoding="utf-8"?>
 <p:sld xmlns:a="http://schemas.openxmlformats.org/drawingml/2006/main" xmlns:r="http://schemas.openxmlformats.org/officeDocument/2006/relationships" xmlns:p="http://schemas.openxmlformats.org/presentationml/2006/main">
-  <p:cSld name="Slide 45">
+  <p:cSld name="Slide 48">
     <p:spTree>
       <p:nvGrpSpPr>
         <p:cNvPr id="1" name=""/>
@@ -18377,7 +19346,7 @@
             <a:pPr algn="ctr"/>
             <a:fld id="{F7021451-1387-4CA6-816F-3879F97B5CBC}" type="slidenum">
               <a:rPr b="1" lang="en-US"/>
-              <a:t>45</a:t>
+              <a:t>48</a:t>
             </a:fld>
             <a:endParaRPr lang="en-US"/>
           </a:p>
@@ -19561,7 +20530,7 @@
         <p:spPr>
           <a:xfrm>
             <a:off x="0" y="658368"/>
-            <a:ext cx="5120640" cy="5833872"/>
+            <a:ext cx="3840480" cy="5833872"/>
           </a:xfrm>
           <a:prstGeom prst="rect">
             <a:avLst/>
@@ -19576,8 +20545,8 @@
         </p:nvSpPr>
         <p:spPr>
           <a:xfrm>
-            <a:off x="5349240" y="1005840"/>
-            <a:ext cx="6522415" cy="731520"/>
+            <a:off x="4069080" y="1005840"/>
+            <a:ext cx="7802575" cy="731520"/>
           </a:xfrm>
           <a:prstGeom prst="rect">
             <a:avLst/>
@@ -19617,8 +20586,8 @@
         </p:nvSpPr>
         <p:spPr>
           <a:xfrm>
-            <a:off x="5349240" y="1783080"/>
-            <a:ext cx="6522415" cy="4663440"/>
+            <a:off x="4069080" y="1783080"/>
+            <a:ext cx="7802575" cy="4663440"/>
           </a:xfrm>
           <a:prstGeom prst="rect">
             <a:avLst/>
@@ -19645,7 +20614,7 @@
                 <a:ea typeface="Times New Roman" pitchFamily="34" charset="-122"/>
                 <a:cs typeface="Times New Roman" pitchFamily="34" charset="-120"/>
               </a:rPr>
-              <a:t>After a heavy storm in Garoua, Halima sees a small channel cut in the red soil beside the road. The water carried sand and stones and dropped them lower down.</a:t>
+              <a:t>After a heavy storm in Garoua, Halima sees a small channel cut in the red soil beside the road. The water has carried sand and stones and dropped them lower down. She asks: "How is the land worn down like this, and what forces do it?"</a:t>
             </a:r>
             <a:endParaRPr lang="en-US" sz="4000" dirty="0"/>
           </a:p>

</xml_diff>